<commit_message>
Add real risk-inspection screenshots to the platform presentation
Replaced icon-illustrated cards with live screenshots (journal table,
map with real ЮРГ geology, generated KPI report) on the three hero
risk-inspection slides, captured via Playwright against the app's demo
data. hydro-monitoring keeps icon illustrations — its Supabase backend
isn't reachable from this sandbox's network policy.
</commit_message>
<xml_diff>
--- a/presentation_platforms_rg_gold.pptx
+++ b/presentation_platforms_rg_gold.pptx
@@ -11857,28 +11857,323 @@
       </p:sp>
       <p:sp>
         <p:nvSpPr>
-          <p:cNvPr id="5" name="Shape 3"/>
-          <p:cNvSpPr/>
-          <p:nvPr/>
-        </p:nvSpPr>
-        <p:spPr>
-          <a:xfrm>
-            <a:off x="502920" y="1783080"/>
-            <a:ext cx="3557930" cy="1554480"/>
+          <p:cNvPr id="5" name="Text 3"/>
+          <p:cNvSpPr/>
+          <p:nvPr/>
+        </p:nvSpPr>
+        <p:spPr>
+          <a:xfrm>
+            <a:off x="502920" y="1828800"/>
+            <a:ext cx="3977640" cy="777240"/>
+          </a:xfrm>
+          <a:prstGeom prst="rect">
+            <a:avLst/>
+          </a:prstGeom>
+          <a:noFill/>
+          <a:ln/>
+        </p:spPr>
+        <p:txBody>
+          <a:bodyPr wrap="square" lIns="0" tIns="0" rIns="0" bIns="0" rtlCol="0" anchor="ctr"/>
+          <a:lstStyle/>
+          <a:p>
+            <a:pPr indent="0" marL="0">
+              <a:lnSpc>
+                <a:spcPts val="1700"/>
+              </a:lnSpc>
+              <a:buNone/>
+            </a:pPr>
+            <a:r>
+              <a:rPr lang="en-US" sz="1300" b="1" dirty="0">
+                <a:solidFill>
+                  <a:srgbClr val="FFFFFF"/>
+                </a:solidFill>
+                <a:latin typeface="Calibri" pitchFamily="34" charset="0"/>
+                <a:ea typeface="Calibri" pitchFamily="34" charset="-122"/>
+                <a:cs typeface="Calibri" pitchFamily="34" charset="-120"/>
+              </a:rPr>
+              <a:t>Таблица с сортировкой, поиском и пагинацией по всем обращениям.</a:t>
+            </a:r>
+            <a:endParaRPr lang="en-US" sz="1300" dirty="0"/>
+          </a:p>
+        </p:txBody>
+      </p:sp>
+      <p:sp>
+        <p:nvSpPr>
+          <p:cNvPr id="6" name="Shape 4"/>
+          <p:cNvSpPr/>
+          <p:nvPr/>
+        </p:nvSpPr>
+        <p:spPr>
+          <a:xfrm>
+            <a:off x="502920" y="2788920"/>
+            <a:ext cx="91440" cy="91440"/>
+          </a:xfrm>
+          <a:prstGeom prst="ellipse">
+            <a:avLst/>
+          </a:prstGeom>
+          <a:solidFill>
+            <a:srgbClr val="F97316"/>
+          </a:solidFill>
+          <a:ln/>
+        </p:spPr>
+      </p:sp>
+      <p:sp>
+        <p:nvSpPr>
+          <p:cNvPr id="7" name="Text 5"/>
+          <p:cNvSpPr/>
+          <p:nvPr/>
+        </p:nvSpPr>
+        <p:spPr>
+          <a:xfrm>
+            <a:off x="740664" y="2688336"/>
+            <a:ext cx="3739896" cy="457200"/>
+          </a:xfrm>
+          <a:prstGeom prst="rect">
+            <a:avLst/>
+          </a:prstGeom>
+          <a:noFill/>
+          <a:ln/>
+        </p:spPr>
+        <p:txBody>
+          <a:bodyPr wrap="square" lIns="0" tIns="0" rIns="0" bIns="0" rtlCol="0" anchor="ctr"/>
+          <a:lstStyle/>
+          <a:p>
+            <a:pPr indent="0" marL="0">
+              <a:lnSpc>
+                <a:spcPts val="1400"/>
+              </a:lnSpc>
+              <a:buNone/>
+            </a:pPr>
+            <a:r>
+              <a:rPr lang="en-US" sz="1100" dirty="0">
+                <a:solidFill>
+                  <a:srgbClr val="AABBCC"/>
+                </a:solidFill>
+                <a:latin typeface="Calibri" pitchFamily="34" charset="0"/>
+                <a:ea typeface="Calibri" pitchFamily="34" charset="-122"/>
+                <a:cs typeface="Calibri" pitchFamily="34" charset="-120"/>
+              </a:rPr>
+              <a:t>Двойной клик по строке — карточка с вкладками «Информация» и «Статус».</a:t>
+            </a:r>
+            <a:endParaRPr lang="en-US" sz="1100" dirty="0"/>
+          </a:p>
+        </p:txBody>
+      </p:sp>
+      <p:sp>
+        <p:nvSpPr>
+          <p:cNvPr id="8" name="Shape 6"/>
+          <p:cNvSpPr/>
+          <p:nvPr/>
+        </p:nvSpPr>
+        <p:spPr>
+          <a:xfrm>
+            <a:off x="502920" y="3355848"/>
+            <a:ext cx="91440" cy="91440"/>
+          </a:xfrm>
+          <a:prstGeom prst="ellipse">
+            <a:avLst/>
+          </a:prstGeom>
+          <a:solidFill>
+            <a:srgbClr val="F97316"/>
+          </a:solidFill>
+          <a:ln/>
+        </p:spPr>
+      </p:sp>
+      <p:sp>
+        <p:nvSpPr>
+          <p:cNvPr id="9" name="Text 7"/>
+          <p:cNvSpPr/>
+          <p:nvPr/>
+        </p:nvSpPr>
+        <p:spPr>
+          <a:xfrm>
+            <a:off x="740664" y="3255264"/>
+            <a:ext cx="3739896" cy="457200"/>
+          </a:xfrm>
+          <a:prstGeom prst="rect">
+            <a:avLst/>
+          </a:prstGeom>
+          <a:noFill/>
+          <a:ln/>
+        </p:spPr>
+        <p:txBody>
+          <a:bodyPr wrap="square" lIns="0" tIns="0" rIns="0" bIns="0" rtlCol="0" anchor="ctr"/>
+          <a:lstStyle/>
+          <a:p>
+            <a:pPr indent="0" marL="0">
+              <a:lnSpc>
+                <a:spcPts val="1400"/>
+              </a:lnSpc>
+              <a:buNone/>
+            </a:pPr>
+            <a:r>
+              <a:rPr lang="en-US" sz="1100" dirty="0">
+                <a:solidFill>
+                  <a:srgbClr val="AABBCC"/>
+                </a:solidFill>
+                <a:latin typeface="Calibri" pitchFamily="34" charset="0"/>
+                <a:ea typeface="Calibri" pitchFamily="34" charset="-122"/>
+                <a:cs typeface="Calibri" pitchFamily="34" charset="-120"/>
+              </a:rPr>
+              <a:t>Закрытие обращения требует комментарий и фото результата.</a:t>
+            </a:r>
+            <a:endParaRPr lang="en-US" sz="1100" dirty="0"/>
+          </a:p>
+        </p:txBody>
+      </p:sp>
+      <p:sp>
+        <p:nvSpPr>
+          <p:cNvPr id="10" name="Shape 8"/>
+          <p:cNvSpPr/>
+          <p:nvPr/>
+        </p:nvSpPr>
+        <p:spPr>
+          <a:xfrm>
+            <a:off x="502920" y="3922776"/>
+            <a:ext cx="91440" cy="91440"/>
+          </a:xfrm>
+          <a:prstGeom prst="ellipse">
+            <a:avLst/>
+          </a:prstGeom>
+          <a:solidFill>
+            <a:srgbClr val="F97316"/>
+          </a:solidFill>
+          <a:ln/>
+        </p:spPr>
+      </p:sp>
+      <p:sp>
+        <p:nvSpPr>
+          <p:cNvPr id="11" name="Text 9"/>
+          <p:cNvSpPr/>
+          <p:nvPr/>
+        </p:nvSpPr>
+        <p:spPr>
+          <a:xfrm>
+            <a:off x="740664" y="3822192"/>
+            <a:ext cx="3739896" cy="457200"/>
+          </a:xfrm>
+          <a:prstGeom prst="rect">
+            <a:avLst/>
+          </a:prstGeom>
+          <a:noFill/>
+          <a:ln/>
+        </p:spPr>
+        <p:txBody>
+          <a:bodyPr wrap="square" lIns="0" tIns="0" rIns="0" bIns="0" rtlCol="0" anchor="ctr"/>
+          <a:lstStyle/>
+          <a:p>
+            <a:pPr indent="0" marL="0">
+              <a:lnSpc>
+                <a:spcPts val="1400"/>
+              </a:lnSpc>
+              <a:buNone/>
+            </a:pPr>
+            <a:r>
+              <a:rPr lang="en-US" sz="1100" dirty="0">
+                <a:solidFill>
+                  <a:srgbClr val="AABBCC"/>
+                </a:solidFill>
+                <a:latin typeface="Calibri" pitchFamily="34" charset="0"/>
+                <a:ea typeface="Calibri" pitchFamily="34" charset="-122"/>
+                <a:cs typeface="Calibri" pitchFamily="34" charset="-120"/>
+              </a:rPr>
+              <a:t>Уровни опасности и «СТОП!»-метка — видно прямо в таблице.</a:t>
+            </a:r>
+            <a:endParaRPr lang="en-US" sz="1100" dirty="0"/>
+          </a:p>
+        </p:txBody>
+      </p:sp>
+      <p:sp>
+        <p:nvSpPr>
+          <p:cNvPr id="12" name="Shape 10"/>
+          <p:cNvSpPr/>
+          <p:nvPr/>
+        </p:nvSpPr>
+        <p:spPr>
+          <a:xfrm>
+            <a:off x="502920" y="4489704"/>
+            <a:ext cx="91440" cy="91440"/>
+          </a:xfrm>
+          <a:prstGeom prst="ellipse">
+            <a:avLst/>
+          </a:prstGeom>
+          <a:solidFill>
+            <a:srgbClr val="F97316"/>
+          </a:solidFill>
+          <a:ln/>
+        </p:spPr>
+      </p:sp>
+      <p:sp>
+        <p:nvSpPr>
+          <p:cNvPr id="13" name="Text 11"/>
+          <p:cNvSpPr/>
+          <p:nvPr/>
+        </p:nvSpPr>
+        <p:spPr>
+          <a:xfrm>
+            <a:off x="740664" y="4389120"/>
+            <a:ext cx="3739896" cy="457200"/>
+          </a:xfrm>
+          <a:prstGeom prst="rect">
+            <a:avLst/>
+          </a:prstGeom>
+          <a:noFill/>
+          <a:ln/>
+        </p:spPr>
+        <p:txBody>
+          <a:bodyPr wrap="square" lIns="0" tIns="0" rIns="0" bIns="0" rtlCol="0" anchor="ctr"/>
+          <a:lstStyle/>
+          <a:p>
+            <a:pPr indent="0" marL="0">
+              <a:lnSpc>
+                <a:spcPts val="1400"/>
+              </a:lnSpc>
+              <a:buNone/>
+            </a:pPr>
+            <a:r>
+              <a:rPr lang="en-US" sz="1100" dirty="0">
+                <a:solidFill>
+                  <a:srgbClr val="AABBCC"/>
+                </a:solidFill>
+                <a:latin typeface="Calibri" pitchFamily="34" charset="0"/>
+                <a:ea typeface="Calibri" pitchFamily="34" charset="-122"/>
+                <a:cs typeface="Calibri" pitchFamily="34" charset="-120"/>
+              </a:rPr>
+              <a:t>Ручное добавление обращения, если сигнал пришёл не через мобильную форму.</a:t>
+            </a:r>
+            <a:endParaRPr lang="en-US" sz="1100" dirty="0"/>
+          </a:p>
+        </p:txBody>
+      </p:sp>
+      <p:sp>
+        <p:nvSpPr>
+          <p:cNvPr id="14" name="Shape 12"/>
+          <p:cNvSpPr/>
+          <p:nvPr/>
+        </p:nvSpPr>
+        <p:spPr>
+          <a:xfrm>
+            <a:off x="4800600" y="1828800"/>
+            <a:ext cx="6803136" cy="4526280"/>
           </a:xfrm>
           <a:prstGeom prst="roundRect">
             <a:avLst>
-              <a:gd name="adj" fmla="val 5294"/>
+              <a:gd name="adj" fmla="val 1414"/>
             </a:avLst>
           </a:prstGeom>
           <a:solidFill>
-            <a:srgbClr val="132840"/>
+            <a:srgbClr val="000000"/>
           </a:solidFill>
-          <a:ln/>
+          <a:ln w="12700">
+            <a:solidFill>
+              <a:srgbClr val="2A3D55"/>
+            </a:solidFill>
+            <a:prstDash val="solid"/>
+          </a:ln>
           <a:effectLst>
-            <a:outerShdw sx="100000" sy="100000" kx="0" ky="0" algn="bl" rotWithShape="0" blurRad="101600" dist="25400" dir="5400000">
+            <a:outerShdw sx="100000" sy="100000" kx="0" ky="0" algn="bl" rotWithShape="0" blurRad="177800" dist="50800" dir="5400000">
               <a:srgbClr val="000000">
-                <a:alpha val="35000"/>
+                <a:alpha val="45000"/>
               </a:srgbClr>
             </a:outerShdw>
           </a:effectLst>
@@ -11886,27 +12181,67 @@
       </p:sp>
       <p:sp>
         <p:nvSpPr>
-          <p:cNvPr id="6" name="Shape 4"/>
-          <p:cNvSpPr/>
-          <p:nvPr/>
-        </p:nvSpPr>
-        <p:spPr>
-          <a:xfrm>
-            <a:off x="704088" y="1965960"/>
-            <a:ext cx="384048" cy="384048"/>
+          <p:cNvPr id="15" name="Shape 13"/>
+          <p:cNvSpPr/>
+          <p:nvPr/>
+        </p:nvSpPr>
+        <p:spPr>
+          <a:xfrm>
+            <a:off x="4946904" y="1924812"/>
+            <a:ext cx="82296" cy="82296"/>
           </a:xfrm>
           <a:prstGeom prst="ellipse">
             <a:avLst/>
           </a:prstGeom>
           <a:solidFill>
-            <a:srgbClr val="F97316"/>
+            <a:srgbClr val="F87171"/>
+          </a:solidFill>
+          <a:ln/>
+        </p:spPr>
+      </p:sp>
+      <p:sp>
+        <p:nvSpPr>
+          <p:cNvPr id="16" name="Shape 14"/>
+          <p:cNvSpPr/>
+          <p:nvPr/>
+        </p:nvSpPr>
+        <p:spPr>
+          <a:xfrm>
+            <a:off x="5129784" y="1924812"/>
+            <a:ext cx="82296" cy="82296"/>
+          </a:xfrm>
+          <a:prstGeom prst="ellipse">
+            <a:avLst/>
+          </a:prstGeom>
+          <a:solidFill>
+            <a:srgbClr val="FB923C"/>
+          </a:solidFill>
+          <a:ln/>
+        </p:spPr>
+      </p:sp>
+      <p:sp>
+        <p:nvSpPr>
+          <p:cNvPr id="17" name="Shape 15"/>
+          <p:cNvSpPr/>
+          <p:nvPr/>
+        </p:nvSpPr>
+        <p:spPr>
+          <a:xfrm>
+            <a:off x="5312664" y="1924812"/>
+            <a:ext cx="82296" cy="82296"/>
+          </a:xfrm>
+          <a:prstGeom prst="ellipse">
+            <a:avLst/>
+          </a:prstGeom>
+          <a:solidFill>
+            <a:srgbClr val="34D399"/>
           </a:solidFill>
           <a:ln/>
         </p:spPr>
       </p:sp>
       <p:pic>
         <p:nvPicPr>
-          <p:cNvPr id="7" name="Image 0" descr="preencoded.png">    </p:cNvPr>
+          <p:cNvPr id="18" name="Image 0" descr="/tmp/claude-0/-home-user-Monitoring-platform/1d8204e5-7a21-57d5-9045-789b9167f5dc/scratchpad/shots/risk-journal.png">    </p:cNvPr>
           <p:cNvPicPr>
             <a:picLocks noChangeAspect="1"/>
           </p:cNvPicPr>
@@ -11920,8 +12255,8 @@
         </p:blipFill>
         <p:spPr>
           <a:xfrm>
-            <a:off x="780898" y="2042770"/>
-            <a:ext cx="230429" cy="230429"/>
+            <a:off x="4800600" y="2103120"/>
+            <a:ext cx="6803136" cy="4251960"/>
           </a:xfrm>
           <a:prstGeom prst="rect">
             <a:avLst/>
@@ -11930,858 +12265,73 @@
       </p:pic>
       <p:sp>
         <p:nvSpPr>
-          <p:cNvPr id="8" name="Text 5"/>
-          <p:cNvSpPr/>
-          <p:nvPr/>
-        </p:nvSpPr>
-        <p:spPr>
-          <a:xfrm>
-            <a:off x="704088" y="2441448"/>
-            <a:ext cx="3155594" cy="310896"/>
-          </a:xfrm>
-          <a:prstGeom prst="rect">
-            <a:avLst/>
-          </a:prstGeom>
-          <a:noFill/>
-          <a:ln/>
-        </p:spPr>
-        <p:txBody>
-          <a:bodyPr wrap="square" lIns="0" tIns="0" rIns="0" bIns="0" rtlCol="0" anchor="ctr"/>
-          <a:lstStyle/>
-          <a:p>
-            <a:pPr indent="0" marL="0">
-              <a:buNone/>
-            </a:pPr>
-            <a:r>
-              <a:rPr lang="en-US" sz="1350" b="1" dirty="0">
-                <a:solidFill>
-                  <a:srgbClr val="FFFFFF"/>
-                </a:solidFill>
-                <a:latin typeface="Calibri" pitchFamily="34" charset="0"/>
-                <a:ea typeface="Calibri" pitchFamily="34" charset="-122"/>
-                <a:cs typeface="Calibri" pitchFamily="34" charset="-120"/>
-              </a:rPr>
-              <a:t>Таблица с поиском</a:t>
-            </a:r>
-            <a:endParaRPr lang="en-US" sz="1350" dirty="0"/>
-          </a:p>
-        </p:txBody>
-      </p:sp>
-      <p:sp>
-        <p:nvSpPr>
-          <p:cNvPr id="9" name="Text 6"/>
-          <p:cNvSpPr/>
-          <p:nvPr/>
-        </p:nvSpPr>
-        <p:spPr>
-          <a:xfrm>
-            <a:off x="704088" y="2734056"/>
-            <a:ext cx="3155594" cy="512064"/>
-          </a:xfrm>
-          <a:prstGeom prst="rect">
-            <a:avLst/>
-          </a:prstGeom>
-          <a:noFill/>
-          <a:ln/>
-        </p:spPr>
-        <p:txBody>
-          <a:bodyPr wrap="square" lIns="0" tIns="0" rIns="0" bIns="0" rtlCol="0" anchor="ctr"/>
-          <a:lstStyle/>
-          <a:p>
-            <a:pPr indent="0" marL="0">
-              <a:lnSpc>
-                <a:spcPts val="1300"/>
-              </a:lnSpc>
-              <a:buNone/>
-            </a:pPr>
-            <a:r>
-              <a:rPr lang="en-US" sz="1050" dirty="0">
-                <a:solidFill>
-                  <a:srgbClr val="AABBCC"/>
-                </a:solidFill>
-                <a:latin typeface="Calibri" pitchFamily="34" charset="0"/>
-                <a:ea typeface="Calibri" pitchFamily="34" charset="-122"/>
-                <a:cs typeface="Calibri" pitchFamily="34" charset="-120"/>
-              </a:rPr>
-              <a:t>Сортировка, поиск и пагинация по всем обращениям — быстрый доступ к любой записи.</a:t>
-            </a:r>
-            <a:endParaRPr lang="en-US" sz="1050" dirty="0"/>
-          </a:p>
-        </p:txBody>
-      </p:sp>
-      <p:sp>
-        <p:nvSpPr>
-          <p:cNvPr id="10" name="Shape 7"/>
-          <p:cNvSpPr/>
-          <p:nvPr/>
-        </p:nvSpPr>
-        <p:spPr>
-          <a:xfrm>
-            <a:off x="4316882" y="1783080"/>
-            <a:ext cx="3557930" cy="1554480"/>
+          <p:cNvPr id="19" name="Shape 16"/>
+          <p:cNvSpPr/>
+          <p:nvPr/>
+        </p:nvSpPr>
+        <p:spPr>
+          <a:xfrm>
+            <a:off x="9226296" y="5897880"/>
+            <a:ext cx="2194560" cy="329184"/>
           </a:xfrm>
           <a:prstGeom prst="roundRect">
             <a:avLst>
-              <a:gd name="adj" fmla="val 5294"/>
+              <a:gd name="adj" fmla="val 16667"/>
             </a:avLst>
           </a:prstGeom>
           <a:solidFill>
-            <a:srgbClr val="132840"/>
+            <a:srgbClr val="08121C"/>
           </a:solidFill>
-          <a:ln/>
-          <a:effectLst>
-            <a:outerShdw sx="100000" sy="100000" kx="0" ky="0" algn="bl" rotWithShape="0" blurRad="101600" dist="25400" dir="5400000">
-              <a:srgbClr val="000000">
-                <a:alpha val="35000"/>
-              </a:srgbClr>
-            </a:outerShdw>
-          </a:effectLst>
-        </p:spPr>
-      </p:sp>
-      <p:sp>
-        <p:nvSpPr>
-          <p:cNvPr id="11" name="Shape 8"/>
-          <p:cNvSpPr/>
-          <p:nvPr/>
-        </p:nvSpPr>
-        <p:spPr>
-          <a:xfrm>
-            <a:off x="4518050" y="1965960"/>
-            <a:ext cx="384048" cy="384048"/>
-          </a:xfrm>
-          <a:prstGeom prst="ellipse">
-            <a:avLst/>
-          </a:prstGeom>
-          <a:solidFill>
-            <a:srgbClr val="F97316"/>
-          </a:solidFill>
-          <a:ln/>
-        </p:spPr>
-      </p:sp>
-      <p:pic>
-        <p:nvPicPr>
-          <p:cNvPr id="12" name="Image 1" descr="preencoded.png">    </p:cNvPr>
-          <p:cNvPicPr>
-            <a:picLocks noChangeAspect="1"/>
-          </p:cNvPicPr>
-          <p:nvPr/>
-        </p:nvPicPr>
-        <p:blipFill>
-          <a:blip r:embed="rId2"/>
-          <a:stretch>
-            <a:fillRect/>
-          </a:stretch>
-        </p:blipFill>
-        <p:spPr>
-          <a:xfrm>
-            <a:off x="4594860" y="2042770"/>
-            <a:ext cx="230429" cy="230429"/>
-          </a:xfrm>
-          <a:prstGeom prst="rect">
-            <a:avLst/>
-          </a:prstGeom>
-        </p:spPr>
-      </p:pic>
-      <p:sp>
-        <p:nvSpPr>
-          <p:cNvPr id="13" name="Text 9"/>
-          <p:cNvSpPr/>
-          <p:nvPr/>
-        </p:nvSpPr>
-        <p:spPr>
-          <a:xfrm>
-            <a:off x="4518050" y="2441448"/>
-            <a:ext cx="3155594" cy="310896"/>
-          </a:xfrm>
-          <a:prstGeom prst="rect">
-            <a:avLst/>
-          </a:prstGeom>
-          <a:noFill/>
-          <a:ln/>
-        </p:spPr>
-        <p:txBody>
-          <a:bodyPr wrap="square" lIns="0" tIns="0" rIns="0" bIns="0" rtlCol="0" anchor="ctr"/>
-          <a:lstStyle/>
-          <a:p>
-            <a:pPr indent="0" marL="0">
-              <a:buNone/>
-            </a:pPr>
-            <a:r>
-              <a:rPr lang="en-US" sz="1350" b="1" dirty="0">
-                <a:solidFill>
-                  <a:srgbClr val="FFFFFF"/>
-                </a:solidFill>
-                <a:latin typeface="Calibri" pitchFamily="34" charset="0"/>
-                <a:ea typeface="Calibri" pitchFamily="34" charset="-122"/>
-                <a:cs typeface="Calibri" pitchFamily="34" charset="-120"/>
-              </a:rPr>
-              <a:t>Карточка обращения</a:t>
-            </a:r>
-            <a:endParaRPr lang="en-US" sz="1350" dirty="0"/>
-          </a:p>
-        </p:txBody>
-      </p:sp>
-      <p:sp>
-        <p:nvSpPr>
-          <p:cNvPr id="14" name="Text 10"/>
-          <p:cNvSpPr/>
-          <p:nvPr/>
-        </p:nvSpPr>
-        <p:spPr>
-          <a:xfrm>
-            <a:off x="4518050" y="2734056"/>
-            <a:ext cx="3155594" cy="512064"/>
-          </a:xfrm>
-          <a:prstGeom prst="rect">
-            <a:avLst/>
-          </a:prstGeom>
-          <a:noFill/>
-          <a:ln/>
-        </p:spPr>
-        <p:txBody>
-          <a:bodyPr wrap="square" lIns="0" tIns="0" rIns="0" bIns="0" rtlCol="0" anchor="ctr"/>
-          <a:lstStyle/>
-          <a:p>
-            <a:pPr indent="0" marL="0">
-              <a:lnSpc>
-                <a:spcPts val="1300"/>
-              </a:lnSpc>
-              <a:buNone/>
-            </a:pPr>
-            <a:r>
-              <a:rPr lang="en-US" sz="1050" dirty="0">
-                <a:solidFill>
-                  <a:srgbClr val="AABBCC"/>
-                </a:solidFill>
-                <a:latin typeface="Calibri" pitchFamily="34" charset="0"/>
-                <a:ea typeface="Calibri" pitchFamily="34" charset="-122"/>
-                <a:cs typeface="Calibri" pitchFamily="34" charset="-120"/>
-              </a:rPr>
-              <a:t>Две вкладки: «Информация» (поля + фото) и «Статус» (открыто / закрыто).</a:t>
-            </a:r>
-            <a:endParaRPr lang="en-US" sz="1050" dirty="0"/>
-          </a:p>
-        </p:txBody>
-      </p:sp>
-      <p:sp>
-        <p:nvSpPr>
-          <p:cNvPr id="15" name="Shape 11"/>
-          <p:cNvSpPr/>
-          <p:nvPr/>
-        </p:nvSpPr>
-        <p:spPr>
-          <a:xfrm>
-            <a:off x="8130845" y="1783080"/>
-            <a:ext cx="3557930" cy="1554480"/>
-          </a:xfrm>
-          <a:prstGeom prst="roundRect">
-            <a:avLst>
-              <a:gd name="adj" fmla="val 5294"/>
-            </a:avLst>
-          </a:prstGeom>
-          <a:solidFill>
-            <a:srgbClr val="132840"/>
-          </a:solidFill>
-          <a:ln/>
-          <a:effectLst>
-            <a:outerShdw sx="100000" sy="100000" kx="0" ky="0" algn="bl" rotWithShape="0" blurRad="101600" dist="25400" dir="5400000">
-              <a:srgbClr val="000000">
-                <a:alpha val="35000"/>
-              </a:srgbClr>
-            </a:outerShdw>
-          </a:effectLst>
-        </p:spPr>
-      </p:sp>
-      <p:sp>
-        <p:nvSpPr>
-          <p:cNvPr id="16" name="Shape 12"/>
-          <p:cNvSpPr/>
-          <p:nvPr/>
-        </p:nvSpPr>
-        <p:spPr>
-          <a:xfrm>
-            <a:off x="8332013" y="1965960"/>
-            <a:ext cx="384048" cy="384048"/>
-          </a:xfrm>
-          <a:prstGeom prst="ellipse">
-            <a:avLst/>
-          </a:prstGeom>
-          <a:solidFill>
-            <a:srgbClr val="F97316"/>
-          </a:solidFill>
-          <a:ln/>
-        </p:spPr>
-      </p:sp>
-      <p:pic>
-        <p:nvPicPr>
-          <p:cNvPr id="17" name="Image 2" descr="preencoded.png">    </p:cNvPr>
-          <p:cNvPicPr>
-            <a:picLocks noChangeAspect="1"/>
-          </p:cNvPicPr>
-          <p:nvPr/>
-        </p:nvPicPr>
-        <p:blipFill>
-          <a:blip r:embed="rId3"/>
-          <a:stretch>
-            <a:fillRect/>
-          </a:stretch>
-        </p:blipFill>
-        <p:spPr>
-          <a:xfrm>
-            <a:off x="8408822" y="2042770"/>
-            <a:ext cx="230429" cy="230429"/>
-          </a:xfrm>
-          <a:prstGeom prst="rect">
-            <a:avLst/>
-          </a:prstGeom>
-        </p:spPr>
-      </p:pic>
-      <p:sp>
-        <p:nvSpPr>
-          <p:cNvPr id="18" name="Text 13"/>
-          <p:cNvSpPr/>
-          <p:nvPr/>
-        </p:nvSpPr>
-        <p:spPr>
-          <a:xfrm>
-            <a:off x="8332013" y="2441448"/>
-            <a:ext cx="3155594" cy="310896"/>
-          </a:xfrm>
-          <a:prstGeom prst="rect">
-            <a:avLst/>
-          </a:prstGeom>
-          <a:noFill/>
-          <a:ln/>
-        </p:spPr>
-        <p:txBody>
-          <a:bodyPr wrap="square" lIns="0" tIns="0" rIns="0" bIns="0" rtlCol="0" anchor="ctr"/>
-          <a:lstStyle/>
-          <a:p>
-            <a:pPr indent="0" marL="0">
-              <a:buNone/>
-            </a:pPr>
-            <a:r>
-              <a:rPr lang="en-US" sz="1350" b="1" dirty="0">
-                <a:solidFill>
-                  <a:srgbClr val="FFFFFF"/>
-                </a:solidFill>
-                <a:latin typeface="Calibri" pitchFamily="34" charset="0"/>
-                <a:ea typeface="Calibri" pitchFamily="34" charset="-122"/>
-                <a:cs typeface="Calibri" pitchFamily="34" charset="-120"/>
-              </a:rPr>
-              <a:t>Закрытие с фото</a:t>
-            </a:r>
-            <a:endParaRPr lang="en-US" sz="1350" dirty="0"/>
-          </a:p>
-        </p:txBody>
-      </p:sp>
-      <p:sp>
-        <p:nvSpPr>
-          <p:cNvPr id="19" name="Text 14"/>
-          <p:cNvSpPr/>
-          <p:nvPr/>
-        </p:nvSpPr>
-        <p:spPr>
-          <a:xfrm>
-            <a:off x="8332013" y="2734056"/>
-            <a:ext cx="3155594" cy="512064"/>
-          </a:xfrm>
-          <a:prstGeom prst="rect">
-            <a:avLst/>
-          </a:prstGeom>
-          <a:noFill/>
-          <a:ln/>
-        </p:spPr>
-        <p:txBody>
-          <a:bodyPr wrap="square" lIns="0" tIns="0" rIns="0" bIns="0" rtlCol="0" anchor="ctr"/>
-          <a:lstStyle/>
-          <a:p>
-            <a:pPr indent="0" marL="0">
-              <a:lnSpc>
-                <a:spcPts val="1300"/>
-              </a:lnSpc>
-              <a:buNone/>
-            </a:pPr>
-            <a:r>
-              <a:rPr lang="en-US" sz="1050" dirty="0">
-                <a:solidFill>
-                  <a:srgbClr val="AABBCC"/>
-                </a:solidFill>
-                <a:latin typeface="Calibri" pitchFamily="34" charset="0"/>
-                <a:ea typeface="Calibri" pitchFamily="34" charset="-122"/>
-                <a:cs typeface="Calibri" pitchFamily="34" charset="-120"/>
-              </a:rPr>
-              <a:t>Форма закрытия требует комментарий и фото результата — фиксация факта устранения риска.</a:t>
-            </a:r>
-            <a:endParaRPr lang="en-US" sz="1050" dirty="0"/>
-          </a:p>
-        </p:txBody>
-      </p:sp>
-      <p:sp>
-        <p:nvSpPr>
-          <p:cNvPr id="20" name="Shape 15"/>
-          <p:cNvSpPr/>
-          <p:nvPr/>
-        </p:nvSpPr>
-        <p:spPr>
-          <a:xfrm>
-            <a:off x="502920" y="3593592"/>
-            <a:ext cx="3557930" cy="1554480"/>
-          </a:xfrm>
-          <a:prstGeom prst="roundRect">
-            <a:avLst>
-              <a:gd name="adj" fmla="val 5294"/>
-            </a:avLst>
-          </a:prstGeom>
-          <a:solidFill>
-            <a:srgbClr val="132840"/>
-          </a:solidFill>
-          <a:ln/>
-          <a:effectLst>
-            <a:outerShdw sx="100000" sy="100000" kx="0" ky="0" algn="bl" rotWithShape="0" blurRad="101600" dist="25400" dir="5400000">
-              <a:srgbClr val="000000">
-                <a:alpha val="35000"/>
-              </a:srgbClr>
-            </a:outerShdw>
-          </a:effectLst>
-        </p:spPr>
-      </p:sp>
-      <p:sp>
-        <p:nvSpPr>
-          <p:cNvPr id="21" name="Shape 16"/>
-          <p:cNvSpPr/>
-          <p:nvPr/>
-        </p:nvSpPr>
-        <p:spPr>
-          <a:xfrm>
-            <a:off x="704088" y="3776472"/>
-            <a:ext cx="384048" cy="384048"/>
-          </a:xfrm>
-          <a:prstGeom prst="ellipse">
-            <a:avLst/>
-          </a:prstGeom>
-          <a:solidFill>
-            <a:srgbClr val="F97316"/>
-          </a:solidFill>
-          <a:ln/>
-        </p:spPr>
-      </p:sp>
-      <p:pic>
-        <p:nvPicPr>
-          <p:cNvPr id="22" name="Image 3" descr="preencoded.png">    </p:cNvPr>
-          <p:cNvPicPr>
-            <a:picLocks noChangeAspect="1"/>
-          </p:cNvPicPr>
-          <p:nvPr/>
-        </p:nvPicPr>
-        <p:blipFill>
-          <a:blip r:embed="rId4"/>
-          <a:stretch>
-            <a:fillRect/>
-          </a:stretch>
-        </p:blipFill>
-        <p:spPr>
-          <a:xfrm>
-            <a:off x="780898" y="3853282"/>
-            <a:ext cx="230429" cy="230429"/>
-          </a:xfrm>
-          <a:prstGeom prst="rect">
-            <a:avLst/>
-          </a:prstGeom>
-        </p:spPr>
-      </p:pic>
-      <p:sp>
-        <p:nvSpPr>
-          <p:cNvPr id="23" name="Text 17"/>
-          <p:cNvSpPr/>
-          <p:nvPr/>
-        </p:nvSpPr>
-        <p:spPr>
-          <a:xfrm>
-            <a:off x="704088" y="4251960"/>
-            <a:ext cx="3155594" cy="310896"/>
-          </a:xfrm>
-          <a:prstGeom prst="rect">
-            <a:avLst/>
-          </a:prstGeom>
-          <a:noFill/>
-          <a:ln/>
-        </p:spPr>
-        <p:txBody>
-          <a:bodyPr wrap="square" lIns="0" tIns="0" rIns="0" bIns="0" rtlCol="0" anchor="ctr"/>
-          <a:lstStyle/>
-          <a:p>
-            <a:pPr indent="0" marL="0">
-              <a:buNone/>
-            </a:pPr>
-            <a:r>
-              <a:rPr lang="en-US" sz="1350" b="1" dirty="0">
-                <a:solidFill>
-                  <a:srgbClr val="FFFFFF"/>
-                </a:solidFill>
-                <a:latin typeface="Calibri" pitchFamily="34" charset="0"/>
-                <a:ea typeface="Calibri" pitchFamily="34" charset="-122"/>
-                <a:cs typeface="Calibri" pitchFamily="34" charset="-120"/>
-              </a:rPr>
-              <a:t>Уровни опасности</a:t>
-            </a:r>
-            <a:endParaRPr lang="en-US" sz="1350" dirty="0"/>
-          </a:p>
-        </p:txBody>
-      </p:sp>
-      <p:sp>
-        <p:nvSpPr>
-          <p:cNvPr id="24" name="Text 18"/>
-          <p:cNvSpPr/>
-          <p:nvPr/>
-        </p:nvSpPr>
-        <p:spPr>
-          <a:xfrm>
-            <a:off x="704088" y="4544568"/>
-            <a:ext cx="3155594" cy="512064"/>
-          </a:xfrm>
-          <a:prstGeom prst="rect">
-            <a:avLst/>
-          </a:prstGeom>
-          <a:noFill/>
-          <a:ln/>
-        </p:spPr>
-        <p:txBody>
-          <a:bodyPr wrap="square" lIns="0" tIns="0" rIns="0" bIns="0" rtlCol="0" anchor="ctr"/>
-          <a:lstStyle/>
-          <a:p>
-            <a:pPr indent="0" marL="0">
-              <a:lnSpc>
-                <a:spcPts val="1300"/>
-              </a:lnSpc>
-              <a:buNone/>
-            </a:pPr>
-            <a:r>
-              <a:rPr lang="en-US" sz="1050" dirty="0">
-                <a:solidFill>
-                  <a:srgbClr val="AABBCC"/>
-                </a:solidFill>
-                <a:latin typeface="Calibri" pitchFamily="34" charset="0"/>
-                <a:ea typeface="Calibri" pitchFamily="34" charset="-122"/>
-                <a:cs typeface="Calibri" pitchFamily="34" charset="-120"/>
-              </a:rPr>
-              <a:t>Каскадные индикаторы опасности, привязанные к конкретному типу риска.</a:t>
-            </a:r>
-            <a:endParaRPr lang="en-US" sz="1050" dirty="0"/>
-          </a:p>
-        </p:txBody>
-      </p:sp>
-      <p:sp>
-        <p:nvSpPr>
-          <p:cNvPr id="25" name="Shape 19"/>
-          <p:cNvSpPr/>
-          <p:nvPr/>
-        </p:nvSpPr>
-        <p:spPr>
-          <a:xfrm>
-            <a:off x="4316882" y="3593592"/>
-            <a:ext cx="3557930" cy="1554480"/>
-          </a:xfrm>
-          <a:prstGeom prst="roundRect">
-            <a:avLst>
-              <a:gd name="adj" fmla="val 5294"/>
-            </a:avLst>
-          </a:prstGeom>
-          <a:solidFill>
-            <a:srgbClr val="132840"/>
-          </a:solidFill>
-          <a:ln/>
-          <a:effectLst>
-            <a:outerShdw sx="100000" sy="100000" kx="0" ky="0" algn="bl" rotWithShape="0" blurRad="101600" dist="25400" dir="5400000">
-              <a:srgbClr val="000000">
-                <a:alpha val="35000"/>
-              </a:srgbClr>
-            </a:outerShdw>
-          </a:effectLst>
-        </p:spPr>
-      </p:sp>
-      <p:sp>
-        <p:nvSpPr>
-          <p:cNvPr id="26" name="Shape 20"/>
-          <p:cNvSpPr/>
-          <p:nvPr/>
-        </p:nvSpPr>
-        <p:spPr>
-          <a:xfrm>
-            <a:off x="4518050" y="3776472"/>
-            <a:ext cx="384048" cy="384048"/>
-          </a:xfrm>
-          <a:prstGeom prst="ellipse">
-            <a:avLst/>
-          </a:prstGeom>
-          <a:solidFill>
-            <a:srgbClr val="F97316"/>
-          </a:solidFill>
-          <a:ln/>
-        </p:spPr>
-      </p:sp>
-      <p:pic>
-        <p:nvPicPr>
-          <p:cNvPr id="27" name="Image 4" descr="preencoded.png">    </p:cNvPr>
-          <p:cNvPicPr>
-            <a:picLocks noChangeAspect="1"/>
-          </p:cNvPicPr>
-          <p:nvPr/>
-        </p:nvPicPr>
-        <p:blipFill>
-          <a:blip r:embed="rId5"/>
-          <a:stretch>
-            <a:fillRect/>
-          </a:stretch>
-        </p:blipFill>
-        <p:spPr>
-          <a:xfrm>
-            <a:off x="4594860" y="3853282"/>
-            <a:ext cx="230429" cy="230429"/>
-          </a:xfrm>
-          <a:prstGeom prst="rect">
-            <a:avLst/>
-          </a:prstGeom>
-        </p:spPr>
-      </p:pic>
-      <p:sp>
-        <p:nvSpPr>
-          <p:cNvPr id="28" name="Text 21"/>
-          <p:cNvSpPr/>
-          <p:nvPr/>
-        </p:nvSpPr>
-        <p:spPr>
-          <a:xfrm>
-            <a:off x="4518050" y="4251960"/>
-            <a:ext cx="3155594" cy="310896"/>
-          </a:xfrm>
-          <a:prstGeom prst="rect">
-            <a:avLst/>
-          </a:prstGeom>
-          <a:noFill/>
-          <a:ln/>
-        </p:spPr>
-        <p:txBody>
-          <a:bodyPr wrap="square" lIns="0" tIns="0" rIns="0" bIns="0" rtlCol="0" anchor="ctr"/>
-          <a:lstStyle/>
-          <a:p>
-            <a:pPr indent="0" marL="0">
-              <a:buNone/>
-            </a:pPr>
-            <a:r>
-              <a:rPr lang="en-US" sz="1350" b="1" dirty="0">
-                <a:solidFill>
-                  <a:srgbClr val="FFFFFF"/>
-                </a:solidFill>
-                <a:latin typeface="Calibri" pitchFamily="34" charset="0"/>
-                <a:ea typeface="Calibri" pitchFamily="34" charset="-122"/>
-                <a:cs typeface="Calibri" pitchFamily="34" charset="-120"/>
-              </a:rPr>
-              <a:t>Ручное добавление</a:t>
-            </a:r>
-            <a:endParaRPr lang="en-US" sz="1350" dirty="0"/>
-          </a:p>
-        </p:txBody>
-      </p:sp>
-      <p:sp>
-        <p:nvSpPr>
-          <p:cNvPr id="29" name="Text 22"/>
-          <p:cNvSpPr/>
-          <p:nvPr/>
-        </p:nvSpPr>
-        <p:spPr>
-          <a:xfrm>
-            <a:off x="4518050" y="4544568"/>
-            <a:ext cx="3155594" cy="512064"/>
-          </a:xfrm>
-          <a:prstGeom prst="rect">
-            <a:avLst/>
-          </a:prstGeom>
-          <a:noFill/>
-          <a:ln/>
-        </p:spPr>
-        <p:txBody>
-          <a:bodyPr wrap="square" lIns="0" tIns="0" rIns="0" bIns="0" rtlCol="0" anchor="ctr"/>
-          <a:lstStyle/>
-          <a:p>
-            <a:pPr indent="0" marL="0">
-              <a:lnSpc>
-                <a:spcPts val="1300"/>
-              </a:lnSpc>
-              <a:buNone/>
-            </a:pPr>
-            <a:r>
-              <a:rPr lang="en-US" sz="1050" dirty="0">
-                <a:solidFill>
-                  <a:srgbClr val="AABBCC"/>
-                </a:solidFill>
-                <a:latin typeface="Calibri" pitchFamily="34" charset="0"/>
-                <a:ea typeface="Calibri" pitchFamily="34" charset="-122"/>
-                <a:cs typeface="Calibri" pitchFamily="34" charset="-120"/>
-              </a:rPr>
-              <a:t>Диспетчер может завести обращение вручную, если сигнал пришёл не через мобильную форму.</a:t>
-            </a:r>
-            <a:endParaRPr lang="en-US" sz="1050" dirty="0"/>
-          </a:p>
-        </p:txBody>
-      </p:sp>
-      <p:sp>
-        <p:nvSpPr>
-          <p:cNvPr id="30" name="Shape 23"/>
-          <p:cNvSpPr/>
-          <p:nvPr/>
-        </p:nvSpPr>
-        <p:spPr>
-          <a:xfrm>
-            <a:off x="8130845" y="3593592"/>
-            <a:ext cx="3557930" cy="1554480"/>
-          </a:xfrm>
-          <a:prstGeom prst="roundRect">
-            <a:avLst>
-              <a:gd name="adj" fmla="val 5294"/>
-            </a:avLst>
-          </a:prstGeom>
-          <a:solidFill>
-            <a:srgbClr val="132840"/>
-          </a:solidFill>
-          <a:ln/>
-          <a:effectLst>
-            <a:outerShdw sx="100000" sy="100000" kx="0" ky="0" algn="bl" rotWithShape="0" blurRad="101600" dist="25400" dir="5400000">
-              <a:srgbClr val="000000">
-                <a:alpha val="35000"/>
-              </a:srgbClr>
-            </a:outerShdw>
-          </a:effectLst>
-        </p:spPr>
-      </p:sp>
-      <p:sp>
-        <p:nvSpPr>
-          <p:cNvPr id="31" name="Shape 24"/>
-          <p:cNvSpPr/>
-          <p:nvPr/>
-        </p:nvSpPr>
-        <p:spPr>
-          <a:xfrm>
-            <a:off x="8332013" y="3776472"/>
-            <a:ext cx="384048" cy="384048"/>
-          </a:xfrm>
-          <a:prstGeom prst="ellipse">
-            <a:avLst/>
-          </a:prstGeom>
-          <a:solidFill>
-            <a:srgbClr val="F97316"/>
-          </a:solidFill>
-          <a:ln/>
-        </p:spPr>
-      </p:sp>
-      <p:pic>
-        <p:nvPicPr>
-          <p:cNvPr id="32" name="Image 5" descr="preencoded.png">    </p:cNvPr>
-          <p:cNvPicPr>
-            <a:picLocks noChangeAspect="1"/>
-          </p:cNvPicPr>
-          <p:nvPr/>
-        </p:nvPicPr>
-        <p:blipFill>
-          <a:blip r:embed="rId6"/>
-          <a:stretch>
-            <a:fillRect/>
-          </a:stretch>
-        </p:blipFill>
-        <p:spPr>
-          <a:xfrm>
-            <a:off x="8408822" y="3853282"/>
-            <a:ext cx="230429" cy="230429"/>
-          </a:xfrm>
-          <a:prstGeom prst="rect">
-            <a:avLst/>
-          </a:prstGeom>
-        </p:spPr>
-      </p:pic>
-      <p:sp>
-        <p:nvSpPr>
-          <p:cNvPr id="33" name="Text 25"/>
-          <p:cNvSpPr/>
-          <p:nvPr/>
-        </p:nvSpPr>
-        <p:spPr>
-          <a:xfrm>
-            <a:off x="8332013" y="4251960"/>
-            <a:ext cx="3155594" cy="310896"/>
-          </a:xfrm>
-          <a:prstGeom prst="rect">
-            <a:avLst/>
-          </a:prstGeom>
-          <a:noFill/>
-          <a:ln/>
-        </p:spPr>
-        <p:txBody>
-          <a:bodyPr wrap="square" lIns="0" tIns="0" rIns="0" bIns="0" rtlCol="0" anchor="ctr"/>
-          <a:lstStyle/>
-          <a:p>
-            <a:pPr indent="0" marL="0">
-              <a:buNone/>
-            </a:pPr>
-            <a:r>
-              <a:rPr lang="en-US" sz="1350" b="1" dirty="0">
-                <a:solidFill>
-                  <a:srgbClr val="FFFFFF"/>
-                </a:solidFill>
-                <a:latin typeface="Calibri" pitchFamily="34" charset="0"/>
-                <a:ea typeface="Calibri" pitchFamily="34" charset="-122"/>
-                <a:cs typeface="Calibri" pitchFamily="34" charset="-120"/>
-              </a:rPr>
-              <a:t>История действий</a:t>
-            </a:r>
-            <a:endParaRPr lang="en-US" sz="1350" dirty="0"/>
-          </a:p>
-        </p:txBody>
-      </p:sp>
-      <p:sp>
-        <p:nvSpPr>
-          <p:cNvPr id="34" name="Text 26"/>
-          <p:cNvSpPr/>
-          <p:nvPr/>
-        </p:nvSpPr>
-        <p:spPr>
-          <a:xfrm>
-            <a:off x="8332013" y="4544568"/>
-            <a:ext cx="3155594" cy="512064"/>
-          </a:xfrm>
-          <a:prstGeom prst="rect">
-            <a:avLst/>
-          </a:prstGeom>
-          <a:noFill/>
-          <a:ln/>
-        </p:spPr>
-        <p:txBody>
-          <a:bodyPr wrap="square" lIns="0" tIns="0" rIns="0" bIns="0" rtlCol="0" anchor="ctr"/>
-          <a:lstStyle/>
-          <a:p>
-            <a:pPr indent="0" marL="0">
-              <a:lnSpc>
-                <a:spcPts val="1300"/>
-              </a:lnSpc>
-              <a:buNone/>
-            </a:pPr>
-            <a:r>
-              <a:rPr lang="en-US" sz="1050" dirty="0">
-                <a:solidFill>
-                  <a:srgbClr val="AABBCC"/>
-                </a:solidFill>
-                <a:latin typeface="Calibri" pitchFamily="34" charset="0"/>
-                <a:ea typeface="Calibri" pitchFamily="34" charset="-122"/>
-                <a:cs typeface="Calibri" pitchFamily="34" charset="-120"/>
-              </a:rPr>
-              <a:t>Полный журнал действий по каждому обращению — кто и когда что сделал.</a:t>
-            </a:r>
-            <a:endParaRPr lang="en-US" sz="1050" dirty="0"/>
-          </a:p>
-        </p:txBody>
-      </p:sp>
-      <p:sp>
-        <p:nvSpPr>
-          <p:cNvPr id="35" name="Text 27"/>
+          <a:ln w="12700">
+            <a:solidFill>
+              <a:srgbClr val="F97316"/>
+            </a:solidFill>
+            <a:prstDash val="solid"/>
+          </a:ln>
+        </p:spPr>
+      </p:sp>
+      <p:sp>
+        <p:nvSpPr>
+          <p:cNvPr id="20" name="Text 17"/>
+          <p:cNvSpPr/>
+          <p:nvPr/>
+        </p:nvSpPr>
+        <p:spPr>
+          <a:xfrm>
+            <a:off x="9226296" y="5897880"/>
+            <a:ext cx="2194560" cy="329184"/>
+          </a:xfrm>
+          <a:prstGeom prst="rect">
+            <a:avLst/>
+          </a:prstGeom>
+          <a:noFill/>
+          <a:ln/>
+        </p:spPr>
+        <p:txBody>
+          <a:bodyPr wrap="square" lIns="0" tIns="0" rIns="0" bIns="0" rtlCol="0" anchor="ctr"/>
+          <a:lstStyle/>
+          <a:p>
+            <a:pPr algn="ctr" indent="0" marL="0">
+              <a:buNone/>
+            </a:pPr>
+            <a:r>
+              <a:rPr lang="en-US" sz="950" b="1" dirty="0">
+                <a:solidFill>
+                  <a:srgbClr val="F97316"/>
+                </a:solidFill>
+                <a:latin typeface="Calibri" pitchFamily="34" charset="0"/>
+                <a:ea typeface="Calibri" pitchFamily="34" charset="-122"/>
+                <a:cs typeface="Calibri" pitchFamily="34" charset="-120"/>
+              </a:rPr>
+              <a:t>РЕАЛЬНЫЙ ИНТЕРФЕЙС</a:t>
+            </a:r>
+            <a:endParaRPr lang="en-US" sz="950" dirty="0"/>
+          </a:p>
+        </p:txBody>
+      </p:sp>
+      <p:sp>
+        <p:nvSpPr>
+          <p:cNvPr id="21" name="Text 18"/>
           <p:cNvSpPr/>
           <p:nvPr/>
         </p:nvSpPr>
@@ -12820,7 +12370,7 @@
       </p:sp>
       <p:sp>
         <p:nvSpPr>
-          <p:cNvPr id="36" name="Text 28"/>
+          <p:cNvPr id="22" name="Text 19"/>
           <p:cNvSpPr/>
           <p:nvPr/>
         </p:nvSpPr>
@@ -13008,14 +12558,56 @@
       </p:sp>
       <p:sp>
         <p:nvSpPr>
-          <p:cNvPr id="5" name="Shape 3"/>
-          <p:cNvSpPr/>
-          <p:nvPr/>
-        </p:nvSpPr>
-        <p:spPr>
-          <a:xfrm>
-            <a:off x="502920" y="1856232"/>
-            <a:ext cx="128016" cy="128016"/>
+          <p:cNvPr id="5" name="Text 3"/>
+          <p:cNvSpPr/>
+          <p:nvPr/>
+        </p:nvSpPr>
+        <p:spPr>
+          <a:xfrm>
+            <a:off x="502920" y="1828800"/>
+            <a:ext cx="3977640" cy="777240"/>
+          </a:xfrm>
+          <a:prstGeom prst="rect">
+            <a:avLst/>
+          </a:prstGeom>
+          <a:noFill/>
+          <a:ln/>
+        </p:spPr>
+        <p:txBody>
+          <a:bodyPr wrap="square" lIns="0" tIns="0" rIns="0" bIns="0" rtlCol="0" anchor="ctr"/>
+          <a:lstStyle/>
+          <a:p>
+            <a:pPr indent="0" marL="0">
+              <a:lnSpc>
+                <a:spcPts val="1700"/>
+              </a:lnSpc>
+              <a:buNone/>
+            </a:pPr>
+            <a:r>
+              <a:rPr lang="en-US" sz="1300" b="1" dirty="0">
+                <a:solidFill>
+                  <a:srgbClr val="FFFFFF"/>
+                </a:solidFill>
+                <a:latin typeface="Calibri" pitchFamily="34" charset="0"/>
+                <a:ea typeface="Calibri" pitchFamily="34" charset="-122"/>
+                <a:cs typeface="Calibri" pitchFamily="34" charset="-120"/>
+              </a:rPr>
+              <a:t>Домены и разломы — те же реальные координаты карьера ЮРГ, что и в гидромониторинге.</a:t>
+            </a:r>
+            <a:endParaRPr lang="en-US" sz="1300" dirty="0"/>
+          </a:p>
+        </p:txBody>
+      </p:sp>
+      <p:sp>
+        <p:nvSpPr>
+          <p:cNvPr id="6" name="Shape 4"/>
+          <p:cNvSpPr/>
+          <p:nvPr/>
+        </p:nvSpPr>
+        <p:spPr>
+          <a:xfrm>
+            <a:off x="502920" y="2788920"/>
+            <a:ext cx="91440" cy="91440"/>
           </a:xfrm>
           <a:prstGeom prst="ellipse">
             <a:avLst/>
@@ -13028,53 +12620,14 @@
       </p:sp>
       <p:sp>
         <p:nvSpPr>
-          <p:cNvPr id="6" name="Text 4"/>
-          <p:cNvSpPr/>
-          <p:nvPr/>
-        </p:nvSpPr>
-        <p:spPr>
-          <a:xfrm>
-            <a:off x="795528" y="1773936"/>
-            <a:ext cx="6199632" cy="274320"/>
-          </a:xfrm>
-          <a:prstGeom prst="rect">
-            <a:avLst/>
-          </a:prstGeom>
-          <a:noFill/>
-          <a:ln/>
-        </p:spPr>
-        <p:txBody>
-          <a:bodyPr wrap="square" lIns="0" tIns="0" rIns="0" bIns="0" rtlCol="0" anchor="ctr"/>
-          <a:lstStyle/>
-          <a:p>
-            <a:pPr indent="0" marL="0">
-              <a:buNone/>
-            </a:pPr>
-            <a:r>
-              <a:rPr lang="en-US" sz="1350" b="1" dirty="0">
-                <a:solidFill>
-                  <a:srgbClr val="FFFFFF"/>
-                </a:solidFill>
-                <a:latin typeface="Calibri" pitchFamily="34" charset="0"/>
-                <a:ea typeface="Calibri" pitchFamily="34" charset="-122"/>
-                <a:cs typeface="Calibri" pitchFamily="34" charset="-120"/>
-              </a:rPr>
-              <a:t>Раскраска по смыслу</a:t>
-            </a:r>
-            <a:endParaRPr lang="en-US" sz="1350" dirty="0"/>
-          </a:p>
-        </p:txBody>
-      </p:sp>
-      <p:sp>
-        <p:nvSpPr>
           <p:cNvPr id="7" name="Text 5"/>
           <p:cNvSpPr/>
           <p:nvPr/>
         </p:nvSpPr>
         <p:spPr>
           <a:xfrm>
-            <a:off x="795528" y="2048256"/>
-            <a:ext cx="6199632" cy="384048"/>
+            <a:off x="740664" y="2688336"/>
+            <a:ext cx="3739896" cy="457200"/>
           </a:xfrm>
           <a:prstGeom prst="rect">
             <a:avLst/>
@@ -13088,7 +12641,7 @@
           <a:p>
             <a:pPr indent="0" marL="0">
               <a:lnSpc>
-                <a:spcPts val="1300"/>
+                <a:spcPts val="1400"/>
               </a:lnSpc>
               <a:buNone/>
             </a:pPr>
@@ -13101,7 +12654,7 @@
                 <a:ea typeface="Calibri" pitchFamily="34" charset="-122"/>
                 <a:cs typeface="Calibri" pitchFamily="34" charset="-120"/>
               </a:rPr>
-              <a:t>Статус, уровень опасности или тип риска — три взаимоисключающих режима цвета точек.</a:t>
+              <a:t>Раскраска по статусу, уровню опасности или типу риска.</a:t>
             </a:r>
             <a:endParaRPr lang="en-US" sz="1100" dirty="0"/>
           </a:p>
@@ -13115,8 +12668,8 @@
         </p:nvSpPr>
         <p:spPr>
           <a:xfrm>
-            <a:off x="502920" y="2514600"/>
-            <a:ext cx="128016" cy="128016"/>
+            <a:off x="502920" y="3355848"/>
+            <a:ext cx="91440" cy="91440"/>
           </a:xfrm>
           <a:prstGeom prst="ellipse">
             <a:avLst/>
@@ -13135,47 +12688,8 @@
         </p:nvSpPr>
         <p:spPr>
           <a:xfrm>
-            <a:off x="795528" y="2432304"/>
-            <a:ext cx="6199632" cy="274320"/>
-          </a:xfrm>
-          <a:prstGeom prst="rect">
-            <a:avLst/>
-          </a:prstGeom>
-          <a:noFill/>
-          <a:ln/>
-        </p:spPr>
-        <p:txBody>
-          <a:bodyPr wrap="square" lIns="0" tIns="0" rIns="0" bIns="0" rtlCol="0" anchor="ctr"/>
-          <a:lstStyle/>
-          <a:p>
-            <a:pPr indent="0" marL="0">
-              <a:buNone/>
-            </a:pPr>
-            <a:r>
-              <a:rPr lang="en-US" sz="1350" b="1" dirty="0">
-                <a:solidFill>
-                  <a:srgbClr val="FFFFFF"/>
-                </a:solidFill>
-                <a:latin typeface="Calibri" pitchFamily="34" charset="0"/>
-                <a:ea typeface="Calibri" pitchFamily="34" charset="-122"/>
-                <a:cs typeface="Calibri" pitchFamily="34" charset="-120"/>
-              </a:rPr>
-              <a:t>Независимый фильтр видимости</a:t>
-            </a:r>
-            <a:endParaRPr lang="en-US" sz="1350" dirty="0"/>
-          </a:p>
-        </p:txBody>
-      </p:sp>
-      <p:sp>
-        <p:nvSpPr>
-          <p:cNvPr id="10" name="Text 8"/>
-          <p:cNvSpPr/>
-          <p:nvPr/>
-        </p:nvSpPr>
-        <p:spPr>
-          <a:xfrm>
-            <a:off x="795528" y="2706624"/>
-            <a:ext cx="6199632" cy="384048"/>
+            <a:off x="740664" y="3255264"/>
+            <a:ext cx="3739896" cy="457200"/>
           </a:xfrm>
           <a:prstGeom prst="rect">
             <a:avLst/>
@@ -13189,7 +12703,7 @@
           <a:p>
             <a:pPr indent="0" marL="0">
               <a:lnSpc>
-                <a:spcPts val="1300"/>
+                <a:spcPts val="1400"/>
               </a:lnSpc>
               <a:buNone/>
             </a:pPr>
@@ -13202,7 +12716,7 @@
                 <a:ea typeface="Calibri" pitchFamily="34" charset="-122"/>
                 <a:cs typeface="Calibri" pitchFamily="34" charset="-120"/>
               </a:rPr>
-              <a:t>Показывать все / только открытые / только закрытые обращения — отдельно от раскраски.</a:t>
+              <a:t>Независимый фильтр видимости: все / открытые / закрытые.</a:t>
             </a:r>
             <a:endParaRPr lang="en-US" sz="1100" dirty="0"/>
           </a:p>
@@ -13210,14 +12724,14 @@
       </p:sp>
       <p:sp>
         <p:nvSpPr>
-          <p:cNvPr id="11" name="Shape 9"/>
-          <p:cNvSpPr/>
-          <p:nvPr/>
-        </p:nvSpPr>
-        <p:spPr>
-          <a:xfrm>
-            <a:off x="502920" y="3172968"/>
-            <a:ext cx="128016" cy="128016"/>
+          <p:cNvPr id="10" name="Shape 8"/>
+          <p:cNvSpPr/>
+          <p:nvPr/>
+        </p:nvSpPr>
+        <p:spPr>
+          <a:xfrm>
+            <a:off x="502920" y="3922776"/>
+            <a:ext cx="91440" cy="91440"/>
           </a:xfrm>
           <a:prstGeom prst="ellipse">
             <a:avLst/>
@@ -13230,53 +12744,14 @@
       </p:sp>
       <p:sp>
         <p:nvSpPr>
-          <p:cNvPr id="12" name="Text 10"/>
-          <p:cNvSpPr/>
-          <p:nvPr/>
-        </p:nvSpPr>
-        <p:spPr>
-          <a:xfrm>
-            <a:off x="795528" y="3090672"/>
-            <a:ext cx="6199632" cy="274320"/>
-          </a:xfrm>
-          <a:prstGeom prst="rect">
-            <a:avLst/>
-          </a:prstGeom>
-          <a:noFill/>
-          <a:ln/>
-        </p:spPr>
-        <p:txBody>
-          <a:bodyPr wrap="square" lIns="0" tIns="0" rIns="0" bIns="0" rtlCol="0" anchor="ctr"/>
-          <a:lstStyle/>
-          <a:p>
-            <a:pPr indent="0" marL="0">
-              <a:buNone/>
-            </a:pPr>
-            <a:r>
-              <a:rPr lang="en-US" sz="1350" b="1" dirty="0">
-                <a:solidFill>
-                  <a:srgbClr val="FFFFFF"/>
-                </a:solidFill>
-                <a:latin typeface="Calibri" pitchFamily="34" charset="0"/>
-                <a:ea typeface="Calibri" pitchFamily="34" charset="-122"/>
-                <a:cs typeface="Calibri" pitchFamily="34" charset="-120"/>
-              </a:rPr>
-              <a:t>Переключатель недель</a:t>
-            </a:r>
-            <a:endParaRPr lang="en-US" sz="1350" dirty="0"/>
-          </a:p>
-        </p:txBody>
-      </p:sp>
-      <p:sp>
-        <p:nvSpPr>
-          <p:cNvPr id="13" name="Text 11"/>
-          <p:cNvSpPr/>
-          <p:nvPr/>
-        </p:nvSpPr>
-        <p:spPr>
-          <a:xfrm>
-            <a:off x="795528" y="3364992"/>
-            <a:ext cx="6199632" cy="384048"/>
+          <p:cNvPr id="11" name="Text 9"/>
+          <p:cNvSpPr/>
+          <p:nvPr/>
+        </p:nvSpPr>
+        <p:spPr>
+          <a:xfrm>
+            <a:off x="740664" y="3822192"/>
+            <a:ext cx="3739896" cy="457200"/>
           </a:xfrm>
           <a:prstGeom prst="rect">
             <a:avLst/>
@@ -13290,7 +12765,7 @@
           <a:p>
             <a:pPr indent="0" marL="0">
               <a:lnSpc>
-                <a:spcPts val="1300"/>
+                <a:spcPts val="1400"/>
               </a:lnSpc>
               <a:buNone/>
             </a:pPr>
@@ -13303,7 +12778,7 @@
                 <a:ea typeface="Calibri" pitchFamily="34" charset="-122"/>
                 <a:cs typeface="Calibri" pitchFamily="34" charset="-120"/>
               </a:rPr>
-              <a:t>Схема и точки фильтруются по неделе — история участка не теряется при новой загрузке.</a:t>
+              <a:t>Переключатель недель — история участка не теряется.</a:t>
             </a:r>
             <a:endParaRPr lang="en-US" sz="1100" dirty="0"/>
           </a:p>
@@ -13311,14 +12786,14 @@
       </p:sp>
       <p:sp>
         <p:nvSpPr>
-          <p:cNvPr id="14" name="Shape 12"/>
-          <p:cNvSpPr/>
-          <p:nvPr/>
-        </p:nvSpPr>
-        <p:spPr>
-          <a:xfrm>
-            <a:off x="502920" y="3831336"/>
-            <a:ext cx="128016" cy="128016"/>
+          <p:cNvPr id="12" name="Shape 10"/>
+          <p:cNvSpPr/>
+          <p:nvPr/>
+        </p:nvSpPr>
+        <p:spPr>
+          <a:xfrm>
+            <a:off x="502920" y="4489704"/>
+            <a:ext cx="91440" cy="91440"/>
           </a:xfrm>
           <a:prstGeom prst="ellipse">
             <a:avLst/>
@@ -13331,53 +12806,14 @@
       </p:sp>
       <p:sp>
         <p:nvSpPr>
-          <p:cNvPr id="15" name="Text 13"/>
-          <p:cNvSpPr/>
-          <p:nvPr/>
-        </p:nvSpPr>
-        <p:spPr>
-          <a:xfrm>
-            <a:off x="795528" y="3749040"/>
-            <a:ext cx="6199632" cy="274320"/>
-          </a:xfrm>
-          <a:prstGeom prst="rect">
-            <a:avLst/>
-          </a:prstGeom>
-          <a:noFill/>
-          <a:ln/>
-        </p:spPr>
-        <p:txBody>
-          <a:bodyPr wrap="square" lIns="0" tIns="0" rIns="0" bIns="0" rtlCol="0" anchor="ctr"/>
-          <a:lstStyle/>
-          <a:p>
-            <a:pPr indent="0" marL="0">
-              <a:buNone/>
-            </a:pPr>
-            <a:r>
-              <a:rPr lang="en-US" sz="1350" b="1" dirty="0">
-                <a:solidFill>
-                  <a:srgbClr val="FFFFFF"/>
-                </a:solidFill>
-                <a:latin typeface="Calibri" pitchFamily="34" charset="0"/>
-                <a:ea typeface="Calibri" pitchFamily="34" charset="-122"/>
-                <a:cs typeface="Calibri" pitchFamily="34" charset="-120"/>
-              </a:rPr>
-              <a:t>Слои геологии</a:t>
-            </a:r>
-            <a:endParaRPr lang="en-US" sz="1350" dirty="0"/>
-          </a:p>
-        </p:txBody>
-      </p:sp>
-      <p:sp>
-        <p:nvSpPr>
-          <p:cNvPr id="16" name="Text 14"/>
-          <p:cNvSpPr/>
-          <p:nvPr/>
-        </p:nvSpPr>
-        <p:spPr>
-          <a:xfrm>
-            <a:off x="795528" y="4023360"/>
-            <a:ext cx="6199632" cy="384048"/>
+          <p:cNvPr id="13" name="Text 11"/>
+          <p:cNvSpPr/>
+          <p:nvPr/>
+        </p:nvSpPr>
+        <p:spPr>
+          <a:xfrm>
+            <a:off x="740664" y="4389120"/>
+            <a:ext cx="3739896" cy="457200"/>
           </a:xfrm>
           <a:prstGeom prst="rect">
             <a:avLst/>
@@ -13391,7 +12827,7 @@
           <a:p>
             <a:pPr indent="0" marL="0">
               <a:lnSpc>
-                <a:spcPts val="1300"/>
+                <a:spcPts val="1400"/>
               </a:lnSpc>
               <a:buNone/>
             </a:pPr>
@@ -13404,7 +12840,7 @@
                 <a:ea typeface="Calibri" pitchFamily="34" charset="-122"/>
                 <a:cs typeface="Calibri" pitchFamily="34" charset="-120"/>
               </a:rPr>
-              <a:t>Разломы и домены — те же реальные координаты карьера ЮРГ, что и в гидромониторинге, только просмотр.</a:t>
+              <a:t>Охват: Карьер ЮРГ, Карьер СРГ, ДСК.</a:t>
             </a:r>
             <a:endParaRPr lang="en-US" sz="1100" dirty="0"/>
           </a:p>
@@ -13412,52 +12848,175 @@
       </p:sp>
       <p:sp>
         <p:nvSpPr>
-          <p:cNvPr id="17" name="Shape 15"/>
-          <p:cNvSpPr/>
-          <p:nvPr/>
-        </p:nvSpPr>
-        <p:spPr>
-          <a:xfrm>
-            <a:off x="7315200" y="1828800"/>
-            <a:ext cx="4373575" cy="4526280"/>
+          <p:cNvPr id="14" name="Shape 12"/>
+          <p:cNvSpPr/>
+          <p:nvPr/>
+        </p:nvSpPr>
+        <p:spPr>
+          <a:xfrm>
+            <a:off x="4800600" y="1828800"/>
+            <a:ext cx="6803136" cy="4526280"/>
           </a:xfrm>
           <a:prstGeom prst="roundRect">
             <a:avLst>
-              <a:gd name="adj" fmla="val 2091"/>
+              <a:gd name="adj" fmla="val 1414"/>
             </a:avLst>
           </a:prstGeom>
           <a:solidFill>
-            <a:srgbClr val="132840"/>
+            <a:srgbClr val="000000"/>
           </a:solidFill>
-          <a:ln/>
-        </p:spPr>
-      </p:sp>
-      <p:sp>
-        <p:nvSpPr>
-          <p:cNvPr id="18" name="Text 16"/>
-          <p:cNvSpPr/>
-          <p:nvPr/>
-        </p:nvSpPr>
-        <p:spPr>
-          <a:xfrm>
-            <a:off x="7543800" y="2029968"/>
-            <a:ext cx="3916375" cy="365760"/>
-          </a:xfrm>
-          <a:prstGeom prst="rect">
-            <a:avLst/>
-          </a:prstGeom>
-          <a:noFill/>
-          <a:ln/>
-        </p:spPr>
-        <p:txBody>
-          <a:bodyPr wrap="square" lIns="0" tIns="0" rIns="0" bIns="0" rtlCol="0" anchor="ctr"/>
-          <a:lstStyle/>
-          <a:p>
-            <a:pPr indent="0" marL="0">
-              <a:buNone/>
-            </a:pPr>
-            <a:r>
-              <a:rPr lang="en-US" sz="1300" b="1" spc="100" kern="0" dirty="0">
+          <a:ln w="12700">
+            <a:solidFill>
+              <a:srgbClr val="2A3D55"/>
+            </a:solidFill>
+            <a:prstDash val="solid"/>
+          </a:ln>
+          <a:effectLst>
+            <a:outerShdw sx="100000" sy="100000" kx="0" ky="0" algn="bl" rotWithShape="0" blurRad="177800" dist="50800" dir="5400000">
+              <a:srgbClr val="000000">
+                <a:alpha val="45000"/>
+              </a:srgbClr>
+            </a:outerShdw>
+          </a:effectLst>
+        </p:spPr>
+      </p:sp>
+      <p:sp>
+        <p:nvSpPr>
+          <p:cNvPr id="15" name="Shape 13"/>
+          <p:cNvSpPr/>
+          <p:nvPr/>
+        </p:nvSpPr>
+        <p:spPr>
+          <a:xfrm>
+            <a:off x="4946904" y="1924812"/>
+            <a:ext cx="82296" cy="82296"/>
+          </a:xfrm>
+          <a:prstGeom prst="ellipse">
+            <a:avLst/>
+          </a:prstGeom>
+          <a:solidFill>
+            <a:srgbClr val="F87171"/>
+          </a:solidFill>
+          <a:ln/>
+        </p:spPr>
+      </p:sp>
+      <p:sp>
+        <p:nvSpPr>
+          <p:cNvPr id="16" name="Shape 14"/>
+          <p:cNvSpPr/>
+          <p:nvPr/>
+        </p:nvSpPr>
+        <p:spPr>
+          <a:xfrm>
+            <a:off x="5129784" y="1924812"/>
+            <a:ext cx="82296" cy="82296"/>
+          </a:xfrm>
+          <a:prstGeom prst="ellipse">
+            <a:avLst/>
+          </a:prstGeom>
+          <a:solidFill>
+            <a:srgbClr val="FB923C"/>
+          </a:solidFill>
+          <a:ln/>
+        </p:spPr>
+      </p:sp>
+      <p:sp>
+        <p:nvSpPr>
+          <p:cNvPr id="17" name="Shape 15"/>
+          <p:cNvSpPr/>
+          <p:nvPr/>
+        </p:nvSpPr>
+        <p:spPr>
+          <a:xfrm>
+            <a:off x="5312664" y="1924812"/>
+            <a:ext cx="82296" cy="82296"/>
+          </a:xfrm>
+          <a:prstGeom prst="ellipse">
+            <a:avLst/>
+          </a:prstGeom>
+          <a:solidFill>
+            <a:srgbClr val="34D399"/>
+          </a:solidFill>
+          <a:ln/>
+        </p:spPr>
+      </p:sp>
+      <p:pic>
+        <p:nvPicPr>
+          <p:cNvPr id="18" name="Image 0" descr="/tmp/claude-0/-home-user-Monitoring-platform/1d8204e5-7a21-57d5-9045-789b9167f5dc/scratchpad/shots/risk-map.png">    </p:cNvPr>
+          <p:cNvPicPr>
+            <a:picLocks noChangeAspect="1"/>
+          </p:cNvPicPr>
+          <p:nvPr/>
+        </p:nvPicPr>
+        <p:blipFill>
+          <a:blip r:embed="rId1"/>
+          <a:stretch>
+            <a:fillRect/>
+          </a:stretch>
+        </p:blipFill>
+        <p:spPr>
+          <a:xfrm>
+            <a:off x="4800600" y="2103120"/>
+            <a:ext cx="6803136" cy="4251960"/>
+          </a:xfrm>
+          <a:prstGeom prst="rect">
+            <a:avLst/>
+          </a:prstGeom>
+        </p:spPr>
+      </p:pic>
+      <p:sp>
+        <p:nvSpPr>
+          <p:cNvPr id="19" name="Shape 16"/>
+          <p:cNvSpPr/>
+          <p:nvPr/>
+        </p:nvSpPr>
+        <p:spPr>
+          <a:xfrm>
+            <a:off x="9226296" y="5897880"/>
+            <a:ext cx="2194560" cy="329184"/>
+          </a:xfrm>
+          <a:prstGeom prst="roundRect">
+            <a:avLst>
+              <a:gd name="adj" fmla="val 16667"/>
+            </a:avLst>
+          </a:prstGeom>
+          <a:solidFill>
+            <a:srgbClr val="08121C"/>
+          </a:solidFill>
+          <a:ln w="12700">
+            <a:solidFill>
+              <a:srgbClr val="F97316"/>
+            </a:solidFill>
+            <a:prstDash val="solid"/>
+          </a:ln>
+        </p:spPr>
+      </p:sp>
+      <p:sp>
+        <p:nvSpPr>
+          <p:cNvPr id="20" name="Text 17"/>
+          <p:cNvSpPr/>
+          <p:nvPr/>
+        </p:nvSpPr>
+        <p:spPr>
+          <a:xfrm>
+            <a:off x="9226296" y="5897880"/>
+            <a:ext cx="2194560" cy="329184"/>
+          </a:xfrm>
+          <a:prstGeom prst="rect">
+            <a:avLst/>
+          </a:prstGeom>
+          <a:noFill/>
+          <a:ln/>
+        </p:spPr>
+        <p:txBody>
+          <a:bodyPr wrap="square" lIns="0" tIns="0" rIns="0" bIns="0" rtlCol="0" anchor="ctr"/>
+          <a:lstStyle/>
+          <a:p>
+            <a:pPr algn="ctr" indent="0" marL="0">
+              <a:buNone/>
+            </a:pPr>
+            <a:r>
+              <a:rPr lang="en-US" sz="950" b="1" dirty="0">
                 <a:solidFill>
                   <a:srgbClr val="F97316"/>
                 </a:solidFill>
@@ -13465,171 +13024,15 @@
                 <a:ea typeface="Calibri" pitchFamily="34" charset="-122"/>
                 <a:cs typeface="Calibri" pitchFamily="34" charset="-120"/>
               </a:rPr>
-              <a:t>ОХВАТ</a:t>
-            </a:r>
-            <a:endParaRPr lang="en-US" sz="1300" dirty="0"/>
-          </a:p>
-        </p:txBody>
-      </p:sp>
-      <p:sp>
-        <p:nvSpPr>
-          <p:cNvPr id="19" name="Text 17"/>
-          <p:cNvSpPr/>
-          <p:nvPr/>
-        </p:nvSpPr>
-        <p:spPr>
-          <a:xfrm>
-            <a:off x="7543800" y="2606040"/>
-            <a:ext cx="3916375" cy="1162202"/>
-          </a:xfrm>
-          <a:prstGeom prst="rect">
-            <a:avLst/>
-          </a:prstGeom>
-          <a:noFill/>
-          <a:ln/>
-        </p:spPr>
-        <p:txBody>
-          <a:bodyPr wrap="square" lIns="0" tIns="0" rIns="0" bIns="0" rtlCol="0" anchor="ctr"/>
-          <a:lstStyle/>
-          <a:p>
-            <a:pPr indent="0" marL="0">
-              <a:buNone/>
-            </a:pPr>
-            <a:r>
-              <a:rPr lang="en-US" sz="2600" b="1" dirty="0">
-                <a:solidFill>
-                  <a:srgbClr val="FFFFFF"/>
-                </a:solidFill>
-                <a:latin typeface="Calibri" pitchFamily="34" charset="0"/>
-                <a:ea typeface="Calibri" pitchFamily="34" charset="-122"/>
-                <a:cs typeface="Calibri" pitchFamily="34" charset="-120"/>
-              </a:rPr>
-              <a:t>3</a:t>
-            </a:r>
-            <a:endParaRPr lang="en-US" sz="2600" dirty="0"/>
-          </a:p>
-        </p:txBody>
-      </p:sp>
-      <p:sp>
-        <p:nvSpPr>
-          <p:cNvPr id="20" name="Text 18"/>
-          <p:cNvSpPr/>
-          <p:nvPr/>
-        </p:nvSpPr>
-        <p:spPr>
-          <a:xfrm>
-            <a:off x="7543800" y="3693262"/>
-            <a:ext cx="3916375" cy="749808"/>
-          </a:xfrm>
-          <a:prstGeom prst="rect">
-            <a:avLst/>
-          </a:prstGeom>
-          <a:noFill/>
-          <a:ln/>
-        </p:spPr>
-        <p:txBody>
-          <a:bodyPr wrap="square" lIns="0" tIns="0" rIns="0" bIns="0" rtlCol="0" anchor="ctr"/>
-          <a:lstStyle/>
-          <a:p>
-            <a:pPr indent="0" marL="0">
-              <a:buNone/>
-            </a:pPr>
-            <a:r>
-              <a:rPr lang="en-US" sz="1050" dirty="0">
-                <a:solidFill>
-                  <a:srgbClr val="AABBCC"/>
-                </a:solidFill>
-                <a:latin typeface="Calibri" pitchFamily="34" charset="0"/>
-                <a:ea typeface="Calibri" pitchFamily="34" charset="-122"/>
-                <a:cs typeface="Calibri" pitchFamily="34" charset="-120"/>
-              </a:rPr>
-              <a:t>участка: Карьер ЮРГ, Карьер СРГ, ДСК</a:t>
-            </a:r>
-            <a:endParaRPr lang="en-US" sz="1050" dirty="0"/>
-          </a:p>
-        </p:txBody>
-      </p:sp>
-      <p:sp>
-        <p:nvSpPr>
-          <p:cNvPr id="21" name="Text 19"/>
-          <p:cNvSpPr/>
-          <p:nvPr/>
-        </p:nvSpPr>
-        <p:spPr>
-          <a:xfrm>
-            <a:off x="7543800" y="4480560"/>
-            <a:ext cx="3916375" cy="1162202"/>
-          </a:xfrm>
-          <a:prstGeom prst="rect">
-            <a:avLst/>
-          </a:prstGeom>
-          <a:noFill/>
-          <a:ln/>
-        </p:spPr>
-        <p:txBody>
-          <a:bodyPr wrap="square" lIns="0" tIns="0" rIns="0" bIns="0" rtlCol="0" anchor="ctr"/>
-          <a:lstStyle/>
-          <a:p>
-            <a:pPr indent="0" marL="0">
-              <a:buNone/>
-            </a:pPr>
-            <a:r>
-              <a:rPr lang="en-US" sz="2600" b="1" dirty="0">
-                <a:solidFill>
-                  <a:srgbClr val="FFFFFF"/>
-                </a:solidFill>
-                <a:latin typeface="Calibri" pitchFamily="34" charset="0"/>
-                <a:ea typeface="Calibri" pitchFamily="34" charset="-122"/>
-                <a:cs typeface="Calibri" pitchFamily="34" charset="-120"/>
-              </a:rPr>
-              <a:t>1:1</a:t>
-            </a:r>
-            <a:endParaRPr lang="en-US" sz="2600" dirty="0"/>
-          </a:p>
-        </p:txBody>
-      </p:sp>
-      <p:sp>
-        <p:nvSpPr>
-          <p:cNvPr id="22" name="Text 20"/>
-          <p:cNvSpPr/>
-          <p:nvPr/>
-        </p:nvSpPr>
-        <p:spPr>
-          <a:xfrm>
-            <a:off x="7543800" y="5567782"/>
-            <a:ext cx="3916375" cy="749808"/>
-          </a:xfrm>
-          <a:prstGeom prst="rect">
-            <a:avLst/>
-          </a:prstGeom>
-          <a:noFill/>
-          <a:ln/>
-        </p:spPr>
-        <p:txBody>
-          <a:bodyPr wrap="square" lIns="0" tIns="0" rIns="0" bIns="0" rtlCol="0" anchor="ctr"/>
-          <a:lstStyle/>
-          <a:p>
-            <a:pPr indent="0" marL="0">
-              <a:buNone/>
-            </a:pPr>
-            <a:r>
-              <a:rPr lang="en-US" sz="1050" dirty="0">
-                <a:solidFill>
-                  <a:srgbClr val="AABBCC"/>
-                </a:solidFill>
-                <a:latin typeface="Calibri" pitchFamily="34" charset="0"/>
-                <a:ea typeface="Calibri" pitchFamily="34" charset="-122"/>
-                <a:cs typeface="Calibri" pitchFamily="34" charset="-120"/>
-              </a:rPr>
-              <a:t>та же геология, что и в гидрогеологическом мониторинге</a:t>
-            </a:r>
-            <a:endParaRPr lang="en-US" sz="1050" dirty="0"/>
-          </a:p>
-        </p:txBody>
-      </p:sp>
-      <p:sp>
-        <p:nvSpPr>
-          <p:cNvPr id="23" name="Text 21"/>
+              <a:t>КАРЬЕР ЮРГ · РЕАЛЬНАЯ ГЕОЛОГИЯ</a:t>
+            </a:r>
+            <a:endParaRPr lang="en-US" sz="950" dirty="0"/>
+          </a:p>
+        </p:txBody>
+      </p:sp>
+      <p:sp>
+        <p:nvSpPr>
+          <p:cNvPr id="21" name="Text 18"/>
           <p:cNvSpPr/>
           <p:nvPr/>
         </p:nvSpPr>
@@ -13668,7 +13071,7 @@
       </p:sp>
       <p:sp>
         <p:nvSpPr>
-          <p:cNvPr id="24" name="Text 22"/>
+          <p:cNvPr id="22" name="Text 19"/>
           <p:cNvSpPr/>
           <p:nvPr/>
         </p:nvSpPr>
@@ -15947,14 +15350,56 @@
       </p:sp>
       <p:sp>
         <p:nvSpPr>
-          <p:cNvPr id="5" name="Shape 3"/>
-          <p:cNvSpPr/>
-          <p:nvPr/>
-        </p:nvSpPr>
-        <p:spPr>
-          <a:xfrm>
-            <a:off x="502920" y="1856232"/>
-            <a:ext cx="128016" cy="128016"/>
+          <p:cNvPr id="5" name="Text 3"/>
+          <p:cNvSpPr/>
+          <p:nvPr/>
+        </p:nvSpPr>
+        <p:spPr>
+          <a:xfrm>
+            <a:off x="502920" y="1828800"/>
+            <a:ext cx="3977640" cy="777240"/>
+          </a:xfrm>
+          <a:prstGeom prst="rect">
+            <a:avLst/>
+          </a:prstGeom>
+          <a:noFill/>
+          <a:ln/>
+        </p:spPr>
+        <p:txBody>
+          <a:bodyPr wrap="square" lIns="0" tIns="0" rIns="0" bIns="0" rtlCol="0" anchor="ctr"/>
+          <a:lstStyle/>
+          <a:p>
+            <a:pPr indent="0" marL="0">
+              <a:lnSpc>
+                <a:spcPts val="1700"/>
+              </a:lnSpc>
+              <a:buNone/>
+            </a:pPr>
+            <a:r>
+              <a:rPr lang="en-US" sz="1300" b="1" dirty="0">
+                <a:solidFill>
+                  <a:srgbClr val="FFFFFF"/>
+                </a:solidFill>
+                <a:latin typeface="Calibri" pitchFamily="34" charset="0"/>
+                <a:ea typeface="Calibri" pitchFamily="34" charset="-122"/>
+                <a:cs typeface="Calibri" pitchFamily="34" charset="-120"/>
+              </a:rPr>
+              <a:t>KPI и разбивки — по каждому выбранному участку, за любой период.</a:t>
+            </a:r>
+            <a:endParaRPr lang="en-US" sz="1300" dirty="0"/>
+          </a:p>
+        </p:txBody>
+      </p:sp>
+      <p:sp>
+        <p:nvSpPr>
+          <p:cNvPr id="6" name="Shape 4"/>
+          <p:cNvSpPr/>
+          <p:nvPr/>
+        </p:nvSpPr>
+        <p:spPr>
+          <a:xfrm>
+            <a:off x="502920" y="2788920"/>
+            <a:ext cx="91440" cy="91440"/>
           </a:xfrm>
           <a:prstGeom prst="ellipse">
             <a:avLst/>
@@ -15967,53 +15412,14 @@
       </p:sp>
       <p:sp>
         <p:nvSpPr>
-          <p:cNvPr id="6" name="Text 4"/>
-          <p:cNvSpPr/>
-          <p:nvPr/>
-        </p:nvSpPr>
-        <p:spPr>
-          <a:xfrm>
-            <a:off x="795528" y="1773936"/>
-            <a:ext cx="6199632" cy="274320"/>
-          </a:xfrm>
-          <a:prstGeom prst="rect">
-            <a:avLst/>
-          </a:prstGeom>
-          <a:noFill/>
-          <a:ln/>
-        </p:spPr>
-        <p:txBody>
-          <a:bodyPr wrap="square" lIns="0" tIns="0" rIns="0" bIns="0" rtlCol="0" anchor="ctr"/>
-          <a:lstStyle/>
-          <a:p>
-            <a:pPr indent="0" marL="0">
-              <a:buNone/>
-            </a:pPr>
-            <a:r>
-              <a:rPr lang="en-US" sz="1350" b="1" dirty="0">
-                <a:solidFill>
-                  <a:srgbClr val="FFFFFF"/>
-                </a:solidFill>
-                <a:latin typeface="Calibri" pitchFamily="34" charset="0"/>
-                <a:ea typeface="Calibri" pitchFamily="34" charset="-122"/>
-                <a:cs typeface="Calibri" pitchFamily="34" charset="-120"/>
-              </a:rPr>
-              <a:t>Гибкий период и фильтры</a:t>
-            </a:r>
-            <a:endParaRPr lang="en-US" sz="1350" dirty="0"/>
-          </a:p>
-        </p:txBody>
-      </p:sp>
-      <p:sp>
-        <p:nvSpPr>
           <p:cNvPr id="7" name="Text 5"/>
           <p:cNvSpPr/>
           <p:nvPr/>
         </p:nvSpPr>
         <p:spPr>
           <a:xfrm>
-            <a:off x="795528" y="2048256"/>
-            <a:ext cx="6199632" cy="384048"/>
+            <a:off x="740664" y="2688336"/>
+            <a:ext cx="3739896" cy="457200"/>
           </a:xfrm>
           <a:prstGeom prst="rect">
             <a:avLst/>
@@ -16027,7 +15433,7 @@
           <a:p>
             <a:pPr indent="0" marL="0">
               <a:lnSpc>
-                <a:spcPts val="1300"/>
+                <a:spcPts val="1400"/>
               </a:lnSpc>
               <a:buNone/>
             </a:pPr>
@@ -16040,7 +15446,7 @@
                 <a:ea typeface="Calibri" pitchFamily="34" charset="-122"/>
                 <a:cs typeface="Calibri" pitchFamily="34" charset="-120"/>
               </a:rPr>
-              <a:t>Пресеты «Сегодня / Неделя / Месяц / Квартал» или произвольные даты, фильтры по статусу и уровню.</a:t>
+              <a:t>Пресеты периода или произвольные даты «С» / «По».</a:t>
             </a:r>
             <a:endParaRPr lang="en-US" sz="1100" dirty="0"/>
           </a:p>
@@ -16054,8 +15460,8 @@
         </p:nvSpPr>
         <p:spPr>
           <a:xfrm>
-            <a:off x="502920" y="2514600"/>
-            <a:ext cx="128016" cy="128016"/>
+            <a:off x="502920" y="3355848"/>
+            <a:ext cx="91440" cy="91440"/>
           </a:xfrm>
           <a:prstGeom prst="ellipse">
             <a:avLst/>
@@ -16074,47 +15480,8 @@
         </p:nvSpPr>
         <p:spPr>
           <a:xfrm>
-            <a:off x="795528" y="2432304"/>
-            <a:ext cx="6199632" cy="274320"/>
-          </a:xfrm>
-          <a:prstGeom prst="rect">
-            <a:avLst/>
-          </a:prstGeom>
-          <a:noFill/>
-          <a:ln/>
-        </p:spPr>
-        <p:txBody>
-          <a:bodyPr wrap="square" lIns="0" tIns="0" rIns="0" bIns="0" rtlCol="0" anchor="ctr"/>
-          <a:lstStyle/>
-          <a:p>
-            <a:pPr indent="0" marL="0">
-              <a:buNone/>
-            </a:pPr>
-            <a:r>
-              <a:rPr lang="en-US" sz="1350" b="1" dirty="0">
-                <a:solidFill>
-                  <a:srgbClr val="FFFFFF"/>
-                </a:solidFill>
-                <a:latin typeface="Calibri" pitchFamily="34" charset="0"/>
-                <a:ea typeface="Calibri" pitchFamily="34" charset="-122"/>
-                <a:cs typeface="Calibri" pitchFamily="34" charset="-120"/>
-              </a:rPr>
-              <a:t>KPI и разбивки</a:t>
-            </a:r>
-            <a:endParaRPr lang="en-US" sz="1350" dirty="0"/>
-          </a:p>
-        </p:txBody>
-      </p:sp>
-      <p:sp>
-        <p:nvSpPr>
-          <p:cNvPr id="10" name="Text 8"/>
-          <p:cNvSpPr/>
-          <p:nvPr/>
-        </p:nvSpPr>
-        <p:spPr>
-          <a:xfrm>
-            <a:off x="795528" y="2706624"/>
-            <a:ext cx="6199632" cy="384048"/>
+            <a:off x="740664" y="3255264"/>
+            <a:ext cx="3739896" cy="457200"/>
           </a:xfrm>
           <a:prstGeom prst="rect">
             <a:avLst/>
@@ -16128,7 +15495,7 @@
           <a:p>
             <a:pPr indent="0" marL="0">
               <a:lnSpc>
-                <a:spcPts val="1300"/>
+                <a:spcPts val="1400"/>
               </a:lnSpc>
               <a:buNone/>
             </a:pPr>
@@ -16141,7 +15508,7 @@
                 <a:ea typeface="Calibri" pitchFamily="34" charset="-122"/>
                 <a:cs typeface="Calibri" pitchFamily="34" charset="-120"/>
               </a:rPr>
-              <a:t>Всего / открыто / закрыто / % закрытых / среднее время закрытия — по каждому выбранному участку.</a:t>
+              <a:t>Отдельная таблица «СТОП!» — просроченные критические обращения.</a:t>
             </a:r>
             <a:endParaRPr lang="en-US" sz="1100" dirty="0"/>
           </a:p>
@@ -16149,14 +15516,14 @@
       </p:sp>
       <p:sp>
         <p:nvSpPr>
-          <p:cNvPr id="11" name="Shape 9"/>
-          <p:cNvSpPr/>
-          <p:nvPr/>
-        </p:nvSpPr>
-        <p:spPr>
-          <a:xfrm>
-            <a:off x="502920" y="3172968"/>
-            <a:ext cx="128016" cy="128016"/>
+          <p:cNvPr id="10" name="Shape 8"/>
+          <p:cNvSpPr/>
+          <p:nvPr/>
+        </p:nvSpPr>
+        <p:spPr>
+          <a:xfrm>
+            <a:off x="502920" y="3922776"/>
+            <a:ext cx="91440" cy="91440"/>
           </a:xfrm>
           <a:prstGeom prst="ellipse">
             <a:avLst/>
@@ -16169,53 +15536,14 @@
       </p:sp>
       <p:sp>
         <p:nvSpPr>
-          <p:cNvPr id="12" name="Text 10"/>
-          <p:cNvSpPr/>
-          <p:nvPr/>
-        </p:nvSpPr>
-        <p:spPr>
-          <a:xfrm>
-            <a:off x="795528" y="3090672"/>
-            <a:ext cx="6199632" cy="274320"/>
-          </a:xfrm>
-          <a:prstGeom prst="rect">
-            <a:avLst/>
-          </a:prstGeom>
-          <a:noFill/>
-          <a:ln/>
-        </p:spPr>
-        <p:txBody>
-          <a:bodyPr wrap="square" lIns="0" tIns="0" rIns="0" bIns="0" rtlCol="0" anchor="ctr"/>
-          <a:lstStyle/>
-          <a:p>
-            <a:pPr indent="0" marL="0">
-              <a:buNone/>
-            </a:pPr>
-            <a:r>
-              <a:rPr lang="en-US" sz="1350" b="1" dirty="0">
-                <a:solidFill>
-                  <a:srgbClr val="FFFFFF"/>
-                </a:solidFill>
-                <a:latin typeface="Calibri" pitchFamily="34" charset="0"/>
-                <a:ea typeface="Calibri" pitchFamily="34" charset="-122"/>
-                <a:cs typeface="Calibri" pitchFamily="34" charset="-120"/>
-              </a:rPr>
-              <a:t>Просроченные критические</a:t>
-            </a:r>
-            <a:endParaRPr lang="en-US" sz="1350" dirty="0"/>
-          </a:p>
-        </p:txBody>
-      </p:sp>
-      <p:sp>
-        <p:nvSpPr>
-          <p:cNvPr id="13" name="Text 11"/>
-          <p:cNvSpPr/>
-          <p:nvPr/>
-        </p:nvSpPr>
-        <p:spPr>
-          <a:xfrm>
-            <a:off x="795528" y="3364992"/>
-            <a:ext cx="6199632" cy="384048"/>
+          <p:cNvPr id="11" name="Text 9"/>
+          <p:cNvSpPr/>
+          <p:nvPr/>
+        </p:nvSpPr>
+        <p:spPr>
+          <a:xfrm>
+            <a:off x="740664" y="3822192"/>
+            <a:ext cx="3739896" cy="457200"/>
           </a:xfrm>
           <a:prstGeom prst="rect">
             <a:avLst/>
@@ -16229,7 +15557,7 @@
           <a:p>
             <a:pPr indent="0" marL="0">
               <a:lnSpc>
-                <a:spcPts val="1300"/>
+                <a:spcPts val="1400"/>
               </a:lnSpc>
               <a:buNone/>
             </a:pPr>
@@ -16242,7 +15570,7 @@
                 <a:ea typeface="Calibri" pitchFamily="34" charset="-122"/>
                 <a:cs typeface="Calibri" pitchFamily="34" charset="-120"/>
               </a:rPr>
-              <a:t>Отдельная таблица «СТОП!» — обращения выше настраиваемого порога просрочки.</a:t>
+              <a:t>Снимок карты на каждую неделю периода в отчёте.</a:t>
             </a:r>
             <a:endParaRPr lang="en-US" sz="1100" dirty="0"/>
           </a:p>
@@ -16250,14 +15578,14 @@
       </p:sp>
       <p:sp>
         <p:nvSpPr>
-          <p:cNvPr id="14" name="Shape 12"/>
-          <p:cNvSpPr/>
-          <p:nvPr/>
-        </p:nvSpPr>
-        <p:spPr>
-          <a:xfrm>
-            <a:off x="502920" y="3831336"/>
-            <a:ext cx="128016" cy="128016"/>
+          <p:cNvPr id="12" name="Shape 10"/>
+          <p:cNvSpPr/>
+          <p:nvPr/>
+        </p:nvSpPr>
+        <p:spPr>
+          <a:xfrm>
+            <a:off x="502920" y="4489704"/>
+            <a:ext cx="91440" cy="91440"/>
           </a:xfrm>
           <a:prstGeom prst="ellipse">
             <a:avLst/>
@@ -16270,53 +15598,14 @@
       </p:sp>
       <p:sp>
         <p:nvSpPr>
-          <p:cNvPr id="15" name="Text 13"/>
-          <p:cNvSpPr/>
-          <p:nvPr/>
-        </p:nvSpPr>
-        <p:spPr>
-          <a:xfrm>
-            <a:off x="795528" y="3749040"/>
-            <a:ext cx="6199632" cy="274320"/>
-          </a:xfrm>
-          <a:prstGeom prst="rect">
-            <a:avLst/>
-          </a:prstGeom>
-          <a:noFill/>
-          <a:ln/>
-        </p:spPr>
-        <p:txBody>
-          <a:bodyPr wrap="square" lIns="0" tIns="0" rIns="0" bIns="0" rtlCol="0" anchor="ctr"/>
-          <a:lstStyle/>
-          <a:p>
-            <a:pPr indent="0" marL="0">
-              <a:buNone/>
-            </a:pPr>
-            <a:r>
-              <a:rPr lang="en-US" sz="1350" b="1" dirty="0">
-                <a:solidFill>
-                  <a:srgbClr val="FFFFFF"/>
-                </a:solidFill>
-                <a:latin typeface="Calibri" pitchFamily="34" charset="0"/>
-                <a:ea typeface="Calibri" pitchFamily="34" charset="-122"/>
-                <a:cs typeface="Calibri" pitchFamily="34" charset="-120"/>
-              </a:rPr>
-              <a:t>Карта по неделям в отчёте</a:t>
-            </a:r>
-            <a:endParaRPr lang="en-US" sz="1350" dirty="0"/>
-          </a:p>
-        </p:txBody>
-      </p:sp>
-      <p:sp>
-        <p:nvSpPr>
-          <p:cNvPr id="16" name="Text 14"/>
-          <p:cNvSpPr/>
-          <p:nvPr/>
-        </p:nvSpPr>
-        <p:spPr>
-          <a:xfrm>
-            <a:off x="795528" y="4023360"/>
-            <a:ext cx="6199632" cy="384048"/>
+          <p:cNvPr id="13" name="Text 11"/>
+          <p:cNvSpPr/>
+          <p:nvPr/>
+        </p:nvSpPr>
+        <p:spPr>
+          <a:xfrm>
+            <a:off x="740664" y="4389120"/>
+            <a:ext cx="3739896" cy="457200"/>
           </a:xfrm>
           <a:prstGeom prst="rect">
             <a:avLst/>
@@ -16330,7 +15619,7 @@
           <a:p>
             <a:pPr indent="0" marL="0">
               <a:lnSpc>
-                <a:spcPts val="1300"/>
+                <a:spcPts val="1400"/>
               </a:lnSpc>
               <a:buNone/>
             </a:pPr>
@@ -16343,7 +15632,7 @@
                 <a:ea typeface="Calibri" pitchFamily="34" charset="-122"/>
                 <a:cs typeface="Calibri" pitchFamily="34" charset="-120"/>
               </a:rPr>
-              <a:t>Снимок карты на каждую неделю периода — рисуется той же функцией, что и живая карта.</a:t>
+              <a:t>Печать / PDF — через диалог браузера, в один клик.</a:t>
             </a:r>
             <a:endParaRPr lang="en-US" sz="1100" dirty="0"/>
           </a:p>
@@ -16351,52 +15640,175 @@
       </p:sp>
       <p:sp>
         <p:nvSpPr>
-          <p:cNvPr id="17" name="Shape 15"/>
-          <p:cNvSpPr/>
-          <p:nvPr/>
-        </p:nvSpPr>
-        <p:spPr>
-          <a:xfrm>
-            <a:off x="7315200" y="1828800"/>
-            <a:ext cx="4373575" cy="4526280"/>
+          <p:cNvPr id="14" name="Shape 12"/>
+          <p:cNvSpPr/>
+          <p:nvPr/>
+        </p:nvSpPr>
+        <p:spPr>
+          <a:xfrm>
+            <a:off x="4800600" y="1828800"/>
+            <a:ext cx="6803136" cy="4526280"/>
           </a:xfrm>
           <a:prstGeom prst="roundRect">
             <a:avLst>
-              <a:gd name="adj" fmla="val 2091"/>
+              <a:gd name="adj" fmla="val 1414"/>
             </a:avLst>
           </a:prstGeom>
           <a:solidFill>
-            <a:srgbClr val="132840"/>
+            <a:srgbClr val="000000"/>
           </a:solidFill>
-          <a:ln/>
-        </p:spPr>
-      </p:sp>
-      <p:sp>
-        <p:nvSpPr>
-          <p:cNvPr id="18" name="Text 16"/>
-          <p:cNvSpPr/>
-          <p:nvPr/>
-        </p:nvSpPr>
-        <p:spPr>
-          <a:xfrm>
-            <a:off x="7543800" y="2029968"/>
-            <a:ext cx="3916375" cy="365760"/>
-          </a:xfrm>
-          <a:prstGeom prst="rect">
-            <a:avLst/>
-          </a:prstGeom>
-          <a:noFill/>
-          <a:ln/>
-        </p:spPr>
-        <p:txBody>
-          <a:bodyPr wrap="square" lIns="0" tIns="0" rIns="0" bIns="0" rtlCol="0" anchor="ctr"/>
-          <a:lstStyle/>
-          <a:p>
-            <a:pPr indent="0" marL="0">
-              <a:buNone/>
-            </a:pPr>
-            <a:r>
-              <a:rPr lang="en-US" sz="1300" b="1" spc="100" kern="0" dirty="0">
+          <a:ln w="12700">
+            <a:solidFill>
+              <a:srgbClr val="2A3D55"/>
+            </a:solidFill>
+            <a:prstDash val="solid"/>
+          </a:ln>
+          <a:effectLst>
+            <a:outerShdw sx="100000" sy="100000" kx="0" ky="0" algn="bl" rotWithShape="0" blurRad="177800" dist="50800" dir="5400000">
+              <a:srgbClr val="000000">
+                <a:alpha val="45000"/>
+              </a:srgbClr>
+            </a:outerShdw>
+          </a:effectLst>
+        </p:spPr>
+      </p:sp>
+      <p:sp>
+        <p:nvSpPr>
+          <p:cNvPr id="15" name="Shape 13"/>
+          <p:cNvSpPr/>
+          <p:nvPr/>
+        </p:nvSpPr>
+        <p:spPr>
+          <a:xfrm>
+            <a:off x="4946904" y="1924812"/>
+            <a:ext cx="82296" cy="82296"/>
+          </a:xfrm>
+          <a:prstGeom prst="ellipse">
+            <a:avLst/>
+          </a:prstGeom>
+          <a:solidFill>
+            <a:srgbClr val="F87171"/>
+          </a:solidFill>
+          <a:ln/>
+        </p:spPr>
+      </p:sp>
+      <p:sp>
+        <p:nvSpPr>
+          <p:cNvPr id="16" name="Shape 14"/>
+          <p:cNvSpPr/>
+          <p:nvPr/>
+        </p:nvSpPr>
+        <p:spPr>
+          <a:xfrm>
+            <a:off x="5129784" y="1924812"/>
+            <a:ext cx="82296" cy="82296"/>
+          </a:xfrm>
+          <a:prstGeom prst="ellipse">
+            <a:avLst/>
+          </a:prstGeom>
+          <a:solidFill>
+            <a:srgbClr val="FB923C"/>
+          </a:solidFill>
+          <a:ln/>
+        </p:spPr>
+      </p:sp>
+      <p:sp>
+        <p:nvSpPr>
+          <p:cNvPr id="17" name="Shape 15"/>
+          <p:cNvSpPr/>
+          <p:nvPr/>
+        </p:nvSpPr>
+        <p:spPr>
+          <a:xfrm>
+            <a:off x="5312664" y="1924812"/>
+            <a:ext cx="82296" cy="82296"/>
+          </a:xfrm>
+          <a:prstGeom prst="ellipse">
+            <a:avLst/>
+          </a:prstGeom>
+          <a:solidFill>
+            <a:srgbClr val="34D399"/>
+          </a:solidFill>
+          <a:ln/>
+        </p:spPr>
+      </p:sp>
+      <p:pic>
+        <p:nvPicPr>
+          <p:cNvPr id="18" name="Image 0" descr="/tmp/claude-0/-home-user-Monitoring-platform/1d8204e5-7a21-57d5-9045-789b9167f5dc/scratchpad/shots/risk-reports-generated.png">    </p:cNvPr>
+          <p:cNvPicPr>
+            <a:picLocks noChangeAspect="1"/>
+          </p:cNvPicPr>
+          <p:nvPr/>
+        </p:nvPicPr>
+        <p:blipFill>
+          <a:blip r:embed="rId1"/>
+          <a:stretch>
+            <a:fillRect/>
+          </a:stretch>
+        </p:blipFill>
+        <p:spPr>
+          <a:xfrm>
+            <a:off x="4800600" y="2103120"/>
+            <a:ext cx="6803136" cy="4251960"/>
+          </a:xfrm>
+          <a:prstGeom prst="rect">
+            <a:avLst/>
+          </a:prstGeom>
+        </p:spPr>
+      </p:pic>
+      <p:sp>
+        <p:nvSpPr>
+          <p:cNvPr id="19" name="Shape 16"/>
+          <p:cNvSpPr/>
+          <p:nvPr/>
+        </p:nvSpPr>
+        <p:spPr>
+          <a:xfrm>
+            <a:off x="9226296" y="5897880"/>
+            <a:ext cx="2194560" cy="329184"/>
+          </a:xfrm>
+          <a:prstGeom prst="roundRect">
+            <a:avLst>
+              <a:gd name="adj" fmla="val 16667"/>
+            </a:avLst>
+          </a:prstGeom>
+          <a:solidFill>
+            <a:srgbClr val="08121C"/>
+          </a:solidFill>
+          <a:ln w="12700">
+            <a:solidFill>
+              <a:srgbClr val="F97316"/>
+            </a:solidFill>
+            <a:prstDash val="solid"/>
+          </a:ln>
+        </p:spPr>
+      </p:sp>
+      <p:sp>
+        <p:nvSpPr>
+          <p:cNvPr id="20" name="Text 17"/>
+          <p:cNvSpPr/>
+          <p:nvPr/>
+        </p:nvSpPr>
+        <p:spPr>
+          <a:xfrm>
+            <a:off x="9226296" y="5897880"/>
+            <a:ext cx="2194560" cy="329184"/>
+          </a:xfrm>
+          <a:prstGeom prst="rect">
+            <a:avLst/>
+          </a:prstGeom>
+          <a:noFill/>
+          <a:ln/>
+        </p:spPr>
+        <p:txBody>
+          <a:bodyPr wrap="square" lIns="0" tIns="0" rIns="0" bIns="0" rtlCol="0" anchor="ctr"/>
+          <a:lstStyle/>
+          <a:p>
+            <a:pPr algn="ctr" indent="0" marL="0">
+              <a:buNone/>
+            </a:pPr>
+            <a:r>
+              <a:rPr lang="en-US" sz="950" b="1" dirty="0">
                 <a:solidFill>
                   <a:srgbClr val="F97316"/>
                 </a:solidFill>
@@ -16404,171 +15816,15 @@
                 <a:ea typeface="Calibri" pitchFamily="34" charset="-122"/>
                 <a:cs typeface="Calibri" pitchFamily="34" charset="-120"/>
               </a:rPr>
-              <a:t>ФОРМАТ</a:t>
-            </a:r>
-            <a:endParaRPr lang="en-US" sz="1300" dirty="0"/>
-          </a:p>
-        </p:txBody>
-      </p:sp>
-      <p:sp>
-        <p:nvSpPr>
-          <p:cNvPr id="19" name="Text 17"/>
-          <p:cNvSpPr/>
-          <p:nvPr/>
-        </p:nvSpPr>
-        <p:spPr>
-          <a:xfrm>
-            <a:off x="7543800" y="2606040"/>
-            <a:ext cx="3916375" cy="1162202"/>
-          </a:xfrm>
-          <a:prstGeom prst="rect">
-            <a:avLst/>
-          </a:prstGeom>
-          <a:noFill/>
-          <a:ln/>
-        </p:spPr>
-        <p:txBody>
-          <a:bodyPr wrap="square" lIns="0" tIns="0" rIns="0" bIns="0" rtlCol="0" anchor="ctr"/>
-          <a:lstStyle/>
-          <a:p>
-            <a:pPr indent="0" marL="0">
-              <a:buNone/>
-            </a:pPr>
-            <a:r>
-              <a:rPr lang="en-US" sz="2600" b="1" dirty="0">
-                <a:solidFill>
-                  <a:srgbClr val="FFFFFF"/>
-                </a:solidFill>
-                <a:latin typeface="Calibri" pitchFamily="34" charset="0"/>
-                <a:ea typeface="Calibri" pitchFamily="34" charset="-122"/>
-                <a:cs typeface="Calibri" pitchFamily="34" charset="-120"/>
-              </a:rPr>
-              <a:t>1 клик</a:t>
-            </a:r>
-            <a:endParaRPr lang="en-US" sz="2600" dirty="0"/>
-          </a:p>
-        </p:txBody>
-      </p:sp>
-      <p:sp>
-        <p:nvSpPr>
-          <p:cNvPr id="20" name="Text 18"/>
-          <p:cNvSpPr/>
-          <p:nvPr/>
-        </p:nvSpPr>
-        <p:spPr>
-          <a:xfrm>
-            <a:off x="7543800" y="3693262"/>
-            <a:ext cx="3916375" cy="749808"/>
-          </a:xfrm>
-          <a:prstGeom prst="rect">
-            <a:avLst/>
-          </a:prstGeom>
-          <a:noFill/>
-          <a:ln/>
-        </p:spPr>
-        <p:txBody>
-          <a:bodyPr wrap="square" lIns="0" tIns="0" rIns="0" bIns="0" rtlCol="0" anchor="ctr"/>
-          <a:lstStyle/>
-          <a:p>
-            <a:pPr indent="0" marL="0">
-              <a:buNone/>
-            </a:pPr>
-            <a:r>
-              <a:rPr lang="en-US" sz="1050" dirty="0">
-                <a:solidFill>
-                  <a:srgbClr val="AABBCC"/>
-                </a:solidFill>
-                <a:latin typeface="Calibri" pitchFamily="34" charset="0"/>
-                <a:ea typeface="Calibri" pitchFamily="34" charset="-122"/>
-                <a:cs typeface="Calibri" pitchFamily="34" charset="-120"/>
-              </a:rPr>
-              <a:t>формирование сводки по всем выбранным участкам</a:t>
-            </a:r>
-            <a:endParaRPr lang="en-US" sz="1050" dirty="0"/>
-          </a:p>
-        </p:txBody>
-      </p:sp>
-      <p:sp>
-        <p:nvSpPr>
-          <p:cNvPr id="21" name="Text 19"/>
-          <p:cNvSpPr/>
-          <p:nvPr/>
-        </p:nvSpPr>
-        <p:spPr>
-          <a:xfrm>
-            <a:off x="7543800" y="4480560"/>
-            <a:ext cx="3916375" cy="1162202"/>
-          </a:xfrm>
-          <a:prstGeom prst="rect">
-            <a:avLst/>
-          </a:prstGeom>
-          <a:noFill/>
-          <a:ln/>
-        </p:spPr>
-        <p:txBody>
-          <a:bodyPr wrap="square" lIns="0" tIns="0" rIns="0" bIns="0" rtlCol="0" anchor="ctr"/>
-          <a:lstStyle/>
-          <a:p>
-            <a:pPr indent="0" marL="0">
-              <a:buNone/>
-            </a:pPr>
-            <a:r>
-              <a:rPr lang="en-US" sz="2600" b="1" dirty="0">
-                <a:solidFill>
-                  <a:srgbClr val="FFFFFF"/>
-                </a:solidFill>
-                <a:latin typeface="Calibri" pitchFamily="34" charset="0"/>
-                <a:ea typeface="Calibri" pitchFamily="34" charset="-122"/>
-                <a:cs typeface="Calibri" pitchFamily="34" charset="-120"/>
-              </a:rPr>
-              <a:t>PDF</a:t>
-            </a:r>
-            <a:endParaRPr lang="en-US" sz="2600" dirty="0"/>
-          </a:p>
-        </p:txBody>
-      </p:sp>
-      <p:sp>
-        <p:nvSpPr>
-          <p:cNvPr id="22" name="Text 20"/>
-          <p:cNvSpPr/>
-          <p:nvPr/>
-        </p:nvSpPr>
-        <p:spPr>
-          <a:xfrm>
-            <a:off x="7543800" y="5567782"/>
-            <a:ext cx="3916375" cy="749808"/>
-          </a:xfrm>
-          <a:prstGeom prst="rect">
-            <a:avLst/>
-          </a:prstGeom>
-          <a:noFill/>
-          <a:ln/>
-        </p:spPr>
-        <p:txBody>
-          <a:bodyPr wrap="square" lIns="0" tIns="0" rIns="0" bIns="0" rtlCol="0" anchor="ctr"/>
-          <a:lstStyle/>
-          <a:p>
-            <a:pPr indent="0" marL="0">
-              <a:buNone/>
-            </a:pPr>
-            <a:r>
-              <a:rPr lang="en-US" sz="1050" dirty="0">
-                <a:solidFill>
-                  <a:srgbClr val="AABBCC"/>
-                </a:solidFill>
-                <a:latin typeface="Calibri" pitchFamily="34" charset="0"/>
-                <a:ea typeface="Calibri" pitchFamily="34" charset="-122"/>
-                <a:cs typeface="Calibri" pitchFamily="34" charset="-120"/>
-              </a:rPr>
-              <a:t>печать через диалог браузера, без отдельного экспорта</a:t>
-            </a:r>
-            <a:endParaRPr lang="en-US" sz="1050" dirty="0"/>
-          </a:p>
-        </p:txBody>
-      </p:sp>
-      <p:sp>
-        <p:nvSpPr>
-          <p:cNvPr id="23" name="Text 21"/>
+              <a:t>СФОРМИРОВАННЫЙ ОТЧЁТ</a:t>
+            </a:r>
+            <a:endParaRPr lang="en-US" sz="950" dirty="0"/>
+          </a:p>
+        </p:txBody>
+      </p:sp>
+      <p:sp>
+        <p:nvSpPr>
+          <p:cNvPr id="21" name="Text 18"/>
           <p:cNvSpPr/>
           <p:nvPr/>
         </p:nvSpPr>
@@ -16607,7 +15863,7 @@
       </p:sp>
       <p:sp>
         <p:nvSpPr>
-          <p:cNvPr id="24" name="Text 22"/>
+          <p:cNvPr id="22" name="Text 19"/>
           <p:cNvSpPr/>
           <p:nvPr/>
         </p:nvSpPr>

</xml_diff>

<commit_message>
Genericize presentation: remove client/site identifiers
Reframed the deck as a capability showcase rather than an internal
case study: dropped all RG-Gold / site-name (ЮРГ/СРГ/ДСК) references
and reworded "участок"/"карьер" mentions to generic "объект" language
throughout. Re-captured the risk-inspection screenshots against
sanitized demo data (generic object names, no real employee names,
emails, or phone numbers).
</commit_message>
<xml_diff>
--- a/presentation_platforms_rg_gold.pptx
+++ b/presentation_platforms_rg_gold.pptx
@@ -3347,7 +3347,7 @@
         <p:spPr>
           <a:xfrm>
             <a:off x="502920" y="640080"/>
-            <a:ext cx="7315200" cy="365760"/>
+            <a:ext cx="9144000" cy="365760"/>
           </a:xfrm>
           <a:prstGeom prst="rect">
             <a:avLst/>
@@ -3371,7 +3371,7 @@
                 <a:ea typeface="Calibri" pitchFamily="34" charset="-122"/>
                 <a:cs typeface="Calibri" pitchFamily="34" charset="-120"/>
               </a:rPr>
-              <a:t>RG-GOLD  ·  КАРЬЕР ЮРГ</a:t>
+              <a:t>НАШИ РАЗРАБОТКИ  ·  ПОРТФОЛИО ПЛАТФОРМ</a:t>
             </a:r>
             <a:endParaRPr lang="en-US" sz="1300" dirty="0"/>
           </a:p>
@@ -3413,7 +3413,7 @@
                 <a:ea typeface="Calibri" pitchFamily="34" charset="-122"/>
                 <a:cs typeface="Calibri" pitchFamily="34" charset="-120"/>
               </a:rPr>
-              <a:t>Цифровая экосистема</a:t>
+              <a:t>Платформы промышленного</a:t>
             </a:r>
             <a:endParaRPr lang="en-US" sz="4000" dirty="0"/>
           </a:p>
@@ -4144,7 +4144,7 @@
                 <a:ea typeface="Calibri" pitchFamily="34" charset="-122"/>
                 <a:cs typeface="Calibri" pitchFamily="34" charset="-120"/>
               </a:rPr>
-              <a:t>Кластеризация, азимут-лучи, статус цветом, подложка — схема карьера или PDF.</a:t>
+              <a:t>Кластеризация, азимут-лучи, статус цветом, подложка — схема объекта или PDF.</a:t>
             </a:r>
             <a:endParaRPr lang="en-US" sz="1050" dirty="0"/>
           </a:p>
@@ -4799,7 +4799,7 @@
                 <a:ea typeface="Calibri" pitchFamily="34" charset="-122"/>
                 <a:cs typeface="Calibri" pitchFamily="34" charset="-120"/>
               </a:rPr>
-              <a:t>RG-Gold · Цифровая экосистема мониторинга</a:t>
+              <a:t>Платформы мониторинга и контроля рисков</a:t>
             </a:r>
             <a:endParaRPr lang="en-US" sz="900" dirty="0"/>
           </a:p>
@@ -6041,7 +6041,7 @@
                 <a:ea typeface="Calibri" pitchFamily="34" charset="-122"/>
                 <a:cs typeface="Calibri" pitchFamily="34" charset="-120"/>
               </a:rPr>
-              <a:t>RG-Gold · Цифровая экосистема мониторинга</a:t>
+              <a:t>Платформы мониторинга и контроля рисков</a:t>
             </a:r>
             <a:endParaRPr lang="en-US" sz="900" dirty="0"/>
           </a:p>
@@ -6884,7 +6884,7 @@
                 <a:ea typeface="Calibri" pitchFamily="34" charset="-122"/>
                 <a:cs typeface="Calibri" pitchFamily="34" charset="-120"/>
               </a:rPr>
-              <a:t>RG-Gold · Цифровая экосистема мониторинга</a:t>
+              <a:t>Платформы мониторинга и контроля рисков</a:t>
             </a:r>
             <a:endParaRPr lang="en-US" sz="900" dirty="0"/>
           </a:p>
@@ -7534,7 +7534,7 @@
                 <a:ea typeface="Calibri" pitchFamily="34" charset="-122"/>
                 <a:cs typeface="Calibri" pitchFamily="34" charset="-120"/>
               </a:rPr>
-              <a:t>Распределение притока по 8 бортам карьера — наглядная секторная диаграмма.</a:t>
+              <a:t>Распределение притока по 8 бортам объекта — наглядная секторная диаграмма.</a:t>
             </a:r>
             <a:endParaRPr lang="en-US" sz="1050" dirty="0"/>
           </a:p>
@@ -8035,7 +8035,7 @@
                 <a:ea typeface="Calibri" pitchFamily="34" charset="-122"/>
                 <a:cs typeface="Calibri" pitchFamily="34" charset="-120"/>
               </a:rPr>
-              <a:t>RG-Gold · Цифровая экосистема мониторинга</a:t>
+              <a:t>Платформы мониторинга и контроля рисков</a:t>
             </a:r>
             <a:endParaRPr lang="en-US" sz="900" dirty="0"/>
           </a:p>
@@ -8385,7 +8385,7 @@
                 <a:ea typeface="Calibri" pitchFamily="34" charset="-122"/>
                 <a:cs typeface="Calibri" pitchFamily="34" charset="-120"/>
               </a:rPr>
-              <a:t>Карьер, участок, автор, дата; один срез или сравнение двух периодов.</a:t>
+              <a:t>Объект наблюдения, автор, дата составления; один срез или сравнение двух периодов.</a:t>
             </a:r>
             <a:endParaRPr lang="en-US" sz="1000" dirty="0"/>
           </a:p>
@@ -8979,7 +8979,7 @@
                 <a:ea typeface="Calibri" pitchFamily="34" charset="-122"/>
                 <a:cs typeface="Calibri" pitchFamily="34" charset="-120"/>
               </a:rPr>
-              <a:t>Google Gemini формирует текстовые выводы строго по загруженным данным — банк готовых промптов по темам.</a:t>
+              <a:t>ИИ формирует текстовые выводы строго по загруженным данным — банк готовых промптов по темам.</a:t>
             </a:r>
             <a:endParaRPr lang="en-US" sz="1000" dirty="0"/>
           </a:p>
@@ -9277,7 +9277,7 @@
                 <a:ea typeface="Calibri" pitchFamily="34" charset="-122"/>
                 <a:cs typeface="Calibri" pitchFamily="34" charset="-120"/>
               </a:rPr>
-              <a:t>RG-Gold · Цифровая экосистема мониторинга</a:t>
+              <a:t>Платформы мониторинга и контроля рисков</a:t>
             </a:r>
             <a:endParaRPr lang="en-US" sz="900" dirty="0"/>
           </a:p>
@@ -10125,7 +10125,7 @@
                 <a:ea typeface="Calibri" pitchFamily="34" charset="-122"/>
                 <a:cs typeface="Calibri" pitchFamily="34" charset="-120"/>
               </a:rPr>
-              <a:t>RG-Gold · Цифровая экосистема мониторинга</a:t>
+              <a:t>Платформы мониторинга и контроля рисков</a:t>
             </a:r>
             <a:endParaRPr lang="en-US" sz="900" dirty="0"/>
           </a:p>
@@ -10336,7 +10336,7 @@
                 <a:ea typeface="Calibri" pitchFamily="34" charset="-122"/>
                 <a:cs typeface="Calibri" pitchFamily="34" charset="-120"/>
               </a:rPr>
-              <a:t>Инспекция участков: журнал обращений по рискам, карта и отчёты для геологической и производственной служб</a:t>
+              <a:t>Журнал обращений по рискам, карта и отчёты для геологической и производственной служб предприятия</a:t>
             </a:r>
             <a:endParaRPr lang="en-US" sz="1500" dirty="0"/>
           </a:p>
@@ -10419,7 +10419,7 @@
                 <a:ea typeface="Calibri" pitchFamily="34" charset="-122"/>
                 <a:cs typeface="Calibri" pitchFamily="34" charset="-120"/>
               </a:rPr>
-              <a:t>RG-Gold · Цифровая экосистема мониторинга</a:t>
+              <a:t>Платформы мониторинга и контроля рисков</a:t>
             </a:r>
             <a:endParaRPr lang="en-US" sz="900" dirty="0"/>
           </a:p>
@@ -10727,7 +10727,7 @@
                 <a:ea typeface="Calibri" pitchFamily="34" charset="-122"/>
                 <a:cs typeface="Calibri" pitchFamily="34" charset="-120"/>
               </a:rPr>
-              <a:t>QR-код на участке</a:t>
+              <a:t>QR-код на объекте</a:t>
             </a:r>
             <a:endParaRPr lang="en-US" sz="1250" dirty="0"/>
           </a:p>
@@ -10769,7 +10769,7 @@
                 <a:ea typeface="Calibri" pitchFamily="34" charset="-122"/>
                 <a:cs typeface="Calibri" pitchFamily="34" charset="-120"/>
               </a:rPr>
-              <a:t>Полевой сотрудник сканирует QR и заполняет мобильную форму — уже работает на предприятии.</a:t>
+              <a:t>Полевой сотрудник сканирует QR и заполняет мобильную форму — простой сбор данных без бумаги.</a:t>
             </a:r>
             <a:endParaRPr lang="en-US" sz="1000" dirty="0"/>
           </a:p>
@@ -11561,7 +11561,7 @@
                 <a:ea typeface="Calibri" pitchFamily="34" charset="-122"/>
                 <a:cs typeface="Calibri" pitchFamily="34" charset="-120"/>
               </a:rPr>
-              <a:t>Сводка по участкам, уровням опасности и просроченным критическим обращениям.</a:t>
+              <a:t>Сводка по объектам, уровням опасности и просроченным критическим обращениям.</a:t>
             </a:r>
             <a:endParaRPr lang="en-US" sz="1000" dirty="0"/>
           </a:p>
@@ -11622,7 +11622,7 @@
                 <a:ea typeface="Calibri" pitchFamily="34" charset="-122"/>
                 <a:cs typeface="Calibri" pitchFamily="34" charset="-120"/>
               </a:rPr>
-              <a:t>Мобильная форма не меняется — новая панель только читает и обрабатывает данные, которые она уже пишет в базу предприятия.</a:t>
+              <a:t>Мобильная форма для полевого сбора не меняется — административная панель только читает и обрабатывает уже поступающие данные.</a:t>
             </a:r>
             <a:endParaRPr lang="en-US" sz="1100" dirty="0"/>
           </a:p>
@@ -11661,7 +11661,7 @@
                 <a:ea typeface="Calibri" pitchFamily="34" charset="-122"/>
                 <a:cs typeface="Calibri" pitchFamily="34" charset="-120"/>
               </a:rPr>
-              <a:t>RG-Gold · Цифровая экосистема мониторинга</a:t>
+              <a:t>Платформы мониторинга и контроля рисков</a:t>
             </a:r>
             <a:endParaRPr lang="en-US" sz="900" dirty="0"/>
           </a:p>
@@ -12241,7 +12241,7 @@
       </p:sp>
       <p:pic>
         <p:nvPicPr>
-          <p:cNvPr id="18" name="Image 0" descr="/tmp/claude-0/-home-user-Monitoring-platform/1d8204e5-7a21-57d5-9045-789b9167f5dc/scratchpad/shots/risk-journal.png">    </p:cNvPr>
+          <p:cNvPr id="18" name="Image 0" descr="/tmp/claude-0/-home-user-Monitoring-platform/1d8204e5-7a21-57d5-9045-789b9167f5dc/scratchpad/shots/g-journal.png">    </p:cNvPr>
           <p:cNvPicPr>
             <a:picLocks noChangeAspect="1"/>
           </p:cNvPicPr>
@@ -12323,7 +12323,7 @@
                 <a:ea typeface="Calibri" pitchFamily="34" charset="-122"/>
                 <a:cs typeface="Calibri" pitchFamily="34" charset="-120"/>
               </a:rPr>
-              <a:t>РЕАЛЬНЫЙ ИНТЕРФЕЙС</a:t>
+              <a:t>ИНТЕРФЕЙС ПЛАТФОРМЫ</a:t>
             </a:r>
             <a:endParaRPr lang="en-US" sz="950" dirty="0"/>
           </a:p>
@@ -12362,7 +12362,7 @@
                 <a:ea typeface="Calibri" pitchFamily="34" charset="-122"/>
                 <a:cs typeface="Calibri" pitchFamily="34" charset="-120"/>
               </a:rPr>
-              <a:t>RG-Gold · Цифровая экосистема мониторинга</a:t>
+              <a:t>Платформы мониторинга и контроля рисков</a:t>
             </a:r>
             <a:endParaRPr lang="en-US" sz="900" dirty="0"/>
           </a:p>
@@ -12511,7 +12511,7 @@
                 <a:ea typeface="Calibri" pitchFamily="34" charset="-122"/>
                 <a:cs typeface="Calibri" pitchFamily="34" charset="-120"/>
               </a:rPr>
-              <a:t>Карта участков</a:t>
+              <a:t>Карта объектов</a:t>
             </a:r>
             <a:endParaRPr lang="en-US" sz="3000" dirty="0"/>
           </a:p>
@@ -12550,7 +12550,7 @@
                 <a:ea typeface="Calibri" pitchFamily="34" charset="-122"/>
                 <a:cs typeface="Calibri" pitchFamily="34" charset="-120"/>
               </a:rPr>
-              <a:t>Обращения на схеме участка — с той же геологией, что и в гидромониторинге</a:t>
+              <a:t>Обращения на схеме объекта — с той же геологией, что и в первом продукте</a:t>
             </a:r>
             <a:endParaRPr lang="en-US" sz="1400" dirty="0"/>
           </a:p>
@@ -12592,7 +12592,7 @@
                 <a:ea typeface="Calibri" pitchFamily="34" charset="-122"/>
                 <a:cs typeface="Calibri" pitchFamily="34" charset="-120"/>
               </a:rPr>
-              <a:t>Домены и разломы — те же реальные координаты карьера ЮРГ, что и в гидромониторинге.</a:t>
+              <a:t>Домены и разломы — те же реальные координаты месторождения, что и в гидрогеологическом мониторинге.</a:t>
             </a:r>
             <a:endParaRPr lang="en-US" sz="1300" dirty="0"/>
           </a:p>
@@ -12778,7 +12778,7 @@
                 <a:ea typeface="Calibri" pitchFamily="34" charset="-122"/>
                 <a:cs typeface="Calibri" pitchFamily="34" charset="-120"/>
               </a:rPr>
-              <a:t>Переключатель недель — история участка не теряется.</a:t>
+              <a:t>Переключатель недель — история объекта не теряется.</a:t>
             </a:r>
             <a:endParaRPr lang="en-US" sz="1100" dirty="0"/>
           </a:p>
@@ -12840,7 +12840,7 @@
                 <a:ea typeface="Calibri" pitchFamily="34" charset="-122"/>
                 <a:cs typeface="Calibri" pitchFamily="34" charset="-120"/>
               </a:rPr>
-              <a:t>Охват: Карьер ЮРГ, Карьер СРГ, ДСК.</a:t>
+              <a:t>Охват: неограниченное число объектов предприятия.</a:t>
             </a:r>
             <a:endParaRPr lang="en-US" sz="1100" dirty="0"/>
           </a:p>
@@ -12942,7 +12942,7 @@
       </p:sp>
       <p:pic>
         <p:nvPicPr>
-          <p:cNvPr id="18" name="Image 0" descr="/tmp/claude-0/-home-user-Monitoring-platform/1d8204e5-7a21-57d5-9045-789b9167f5dc/scratchpad/shots/risk-map.png">    </p:cNvPr>
+          <p:cNvPr id="18" name="Image 0" descr="/tmp/claude-0/-home-user-Monitoring-platform/1d8204e5-7a21-57d5-9045-789b9167f5dc/scratchpad/shots/g-map.png">    </p:cNvPr>
           <p:cNvPicPr>
             <a:picLocks noChangeAspect="1"/>
           </p:cNvPicPr>
@@ -13024,7 +13024,7 @@
                 <a:ea typeface="Calibri" pitchFamily="34" charset="-122"/>
                 <a:cs typeface="Calibri" pitchFamily="34" charset="-120"/>
               </a:rPr>
-              <a:t>КАРЬЕР ЮРГ · РЕАЛЬНАЯ ГЕОЛОГИЯ</a:t>
+              <a:t>РЕАЛЬНАЯ ГЕОЛОГИЯ МЕСТОРОЖДЕНИЯ</a:t>
             </a:r>
             <a:endParaRPr lang="en-US" sz="950" dirty="0"/>
           </a:p>
@@ -13063,7 +13063,7 @@
                 <a:ea typeface="Calibri" pitchFamily="34" charset="-122"/>
                 <a:cs typeface="Calibri" pitchFamily="34" charset="-120"/>
               </a:rPr>
-              <a:t>RG-Gold · Цифровая экосистема мониторинга</a:t>
+              <a:t>Платформы мониторинга и контроля рисков</a:t>
             </a:r>
             <a:endParaRPr lang="en-US" sz="900" dirty="0"/>
           </a:p>
@@ -13644,7 +13644,7 @@
                 <a:ea typeface="Calibri" pitchFamily="34" charset="-122"/>
                 <a:cs typeface="Calibri" pitchFamily="34" charset="-120"/>
               </a:rPr>
-              <a:t>✗  Нет привязки к актуальной карте участка</a:t>
+              <a:t>✗  Нет привязки к актуальной карте объекта</a:t>
             </a:r>
             <a:endParaRPr lang="en-US" sz="1150" dirty="0"/>
           </a:p>
@@ -14003,7 +14003,7 @@
                 <a:ea typeface="Calibri" pitchFamily="34" charset="-122"/>
                 <a:cs typeface="Calibri" pitchFamily="34" charset="-120"/>
               </a:rPr>
-              <a:t>RG-Gold · Цифровая экосистема мониторинга</a:t>
+              <a:t>Платформы мониторинга и контроля рисков</a:t>
             </a:r>
             <a:endParaRPr lang="en-US" sz="900" dirty="0"/>
           </a:p>
@@ -14303,7 +14303,7 @@
                 <a:ea typeface="Calibri" pitchFamily="34" charset="-122"/>
                 <a:cs typeface="Calibri" pitchFamily="34" charset="-120"/>
               </a:rPr>
-              <a:t>Названия участков</a:t>
+              <a:t>Названия объектов</a:t>
             </a:r>
             <a:endParaRPr lang="en-US" sz="1350" dirty="0"/>
           </a:p>
@@ -14345,7 +14345,7 @@
                 <a:ea typeface="Calibri" pitchFamily="34" charset="-122"/>
                 <a:cs typeface="Calibri" pitchFamily="34" charset="-120"/>
               </a:rPr>
-              <a:t>Единый справочник участков предприятия для журнала, карты и отчётов.</a:t>
+              <a:t>Единый справочник объектов предприятия для журнала, карты и отчётов.</a:t>
             </a:r>
             <a:endParaRPr lang="en-US" sz="1050" dirty="0"/>
           </a:p>
@@ -14765,7 +14765,7 @@
                 <a:ea typeface="Calibri" pitchFamily="34" charset="-122"/>
                 <a:cs typeface="Calibri" pitchFamily="34" charset="-120"/>
               </a:rPr>
-              <a:t>Схемы участков по неделям</a:t>
+              <a:t>Схемы объектов по неделям</a:t>
             </a:r>
             <a:endParaRPr lang="en-US" sz="1350" dirty="0"/>
           </a:p>
@@ -15154,7 +15154,7 @@
                 <a:ea typeface="Calibri" pitchFamily="34" charset="-122"/>
                 <a:cs typeface="Calibri" pitchFamily="34" charset="-120"/>
               </a:rPr>
-              <a:t>RG-Gold · Цифровая экосистема мониторинга</a:t>
+              <a:t>Платформы мониторинга и контроля рисков</a:t>
             </a:r>
             <a:endParaRPr lang="en-US" sz="900" dirty="0"/>
           </a:p>
@@ -15342,7 +15342,7 @@
                 <a:ea typeface="Calibri" pitchFamily="34" charset="-122"/>
                 <a:cs typeface="Calibri" pitchFamily="34" charset="-120"/>
               </a:rPr>
-              <a:t>Сводка по участкам за период — по клику, без ручной сборки</a:t>
+              <a:t>Сводка по объектам за период — по клику, без ручной сборки</a:t>
             </a:r>
             <a:endParaRPr lang="en-US" sz="1400" dirty="0"/>
           </a:p>
@@ -15384,7 +15384,7 @@
                 <a:ea typeface="Calibri" pitchFamily="34" charset="-122"/>
                 <a:cs typeface="Calibri" pitchFamily="34" charset="-120"/>
               </a:rPr>
-              <a:t>KPI и разбивки — по каждому выбранному участку, за любой период.</a:t>
+              <a:t>KPI и разбивки — по каждому выбранному объекту, за любой период.</a:t>
             </a:r>
             <a:endParaRPr lang="en-US" sz="1300" dirty="0"/>
           </a:p>
@@ -15734,7 +15734,7 @@
       </p:sp>
       <p:pic>
         <p:nvPicPr>
-          <p:cNvPr id="18" name="Image 0" descr="/tmp/claude-0/-home-user-Monitoring-platform/1d8204e5-7a21-57d5-9045-789b9167f5dc/scratchpad/shots/risk-reports-generated.png">    </p:cNvPr>
+          <p:cNvPr id="18" name="Image 0" descr="/tmp/claude-0/-home-user-Monitoring-platform/1d8204e5-7a21-57d5-9045-789b9167f5dc/scratchpad/shots/g-reports.png">    </p:cNvPr>
           <p:cNvPicPr>
             <a:picLocks noChangeAspect="1"/>
           </p:cNvPicPr>
@@ -15855,7 +15855,7 @@
                 <a:ea typeface="Calibri" pitchFamily="34" charset="-122"/>
                 <a:cs typeface="Calibri" pitchFamily="34" charset="-120"/>
               </a:rPr>
-              <a:t>RG-Gold · Цифровая экосистема мониторинга</a:t>
+              <a:t>Платформы мониторинга и контроля рисков</a:t>
             </a:r>
             <a:endParaRPr lang="en-US" sz="900" dirty="0"/>
           </a:p>
@@ -16351,7 +16351,7 @@
                 <a:ea typeface="Calibri" pitchFamily="34" charset="-122"/>
                 <a:cs typeface="Calibri" pitchFamily="34" charset="-120"/>
               </a:rPr>
-              <a:t>Справочник лиц, отвечающих за реагирование на участках.</a:t>
+              <a:t>Справочник лиц, отвечающих за реагирование на объектах.</a:t>
             </a:r>
             <a:endParaRPr lang="en-US" sz="1050" dirty="0"/>
           </a:p>
@@ -16698,7 +16698,7 @@
                 <a:ea typeface="Calibri" pitchFamily="34" charset="-122"/>
                 <a:cs typeface="Calibri" pitchFamily="34" charset="-120"/>
               </a:rPr>
-              <a:t>RG-Gold · Цифровая экосистема мониторинга</a:t>
+              <a:t>Платформы мониторинга и контроля рисков</a:t>
             </a:r>
             <a:endParaRPr lang="en-US" sz="900" dirty="0"/>
           </a:p>
@@ -16886,7 +16886,7 @@
                 <a:ea typeface="Calibri" pitchFamily="34" charset="-122"/>
                 <a:cs typeface="Calibri" pitchFamily="34" charset="-120"/>
               </a:rPr>
-              <a:t>Панель готова, контракт с базой предприятия полностью специфицирован</a:t>
+              <a:t>Панель готова, контракт с боевой базой данных полностью специфицирован</a:t>
             </a:r>
             <a:endParaRPr lang="en-US" sz="1400" dirty="0"/>
           </a:p>
@@ -16945,7 +16945,7 @@
                 <a:ea typeface="Calibri" pitchFamily="34" charset="-122"/>
                 <a:cs typeface="Calibri" pitchFamily="34" charset="-120"/>
               </a:rPr>
-              <a:t>Сейчас: тестовая модель</a:t>
+              <a:t>Сейчас: протестированная модель</a:t>
             </a:r>
             <a:endParaRPr lang="en-US" sz="1350" dirty="0"/>
           </a:p>
@@ -16987,7 +16987,7 @@
                 <a:ea typeface="Calibri" pitchFamily="34" charset="-122"/>
                 <a:cs typeface="Calibri" pitchFamily="34" charset="-120"/>
               </a:rPr>
-              <a:t>UI и логика полностью работают на локальных данных браузера — для демонстрации и приёмки.</a:t>
+              <a:t>UI и логика полностью работают на демонстрационных данных — готова к приёмке заказчиком.</a:t>
             </a:r>
             <a:endParaRPr lang="en-US" sz="1100" dirty="0"/>
           </a:p>
@@ -17147,7 +17147,7 @@
                 <a:ea typeface="Calibri" pitchFamily="34" charset="-122"/>
                 <a:cs typeface="Calibri" pitchFamily="34" charset="-120"/>
               </a:rPr>
-              <a:t>Мобильная форма не меняется</a:t>
+              <a:t>Мобильный сбор данных не меняется</a:t>
             </a:r>
             <a:endParaRPr lang="en-US" sz="1350" dirty="0"/>
           </a:p>
@@ -17189,7 +17189,7 @@
                 <a:ea typeface="Calibri" pitchFamily="34" charset="-122"/>
                 <a:cs typeface="Calibri" pitchFamily="34" charset="-120"/>
               </a:rPr>
-              <a:t>Панель подключается поверх уже работающего сбора данных (QR + форма → SQL Server).</a:t>
+              <a:t>Панель подключается поверх уже работающего сбора данных (QR + форма → боевая база).</a:t>
             </a:r>
             <a:endParaRPr lang="en-US" sz="1100" dirty="0"/>
           </a:p>
@@ -17507,7 +17507,7 @@
                 <a:ea typeface="Calibri" pitchFamily="34" charset="-122"/>
                 <a:cs typeface="Calibri" pitchFamily="34" charset="-120"/>
               </a:rPr>
-              <a:t>контракт с IT-отделом описан по каждому эндпоинту</a:t>
+              <a:t>контракт с IT-отделом заказчика описан по каждому эндпоинту</a:t>
             </a:r>
             <a:endParaRPr lang="en-US" sz="1050" dirty="0"/>
           </a:p>
@@ -17546,7 +17546,7 @@
                 <a:ea typeface="Calibri" pitchFamily="34" charset="-122"/>
                 <a:cs typeface="Calibri" pitchFamily="34" charset="-120"/>
               </a:rPr>
-              <a:t>RG-Gold · Цифровая экосистема мониторинга</a:t>
+              <a:t>Платформы мониторинга и контроля рисков</a:t>
             </a:r>
             <a:endParaRPr lang="en-US" sz="900" dirty="0"/>
           </a:p>
@@ -18000,7 +18000,7 @@
                 <a:ea typeface="Calibri" pitchFamily="34" charset="-122"/>
                 <a:cs typeface="Calibri" pitchFamily="34" charset="-120"/>
               </a:rPr>
-              <a:t>Фиксация рисков: контур предприятия</a:t>
+              <a:t>Фиксация рисков: контур заказчика</a:t>
             </a:r>
             <a:endParaRPr lang="en-US" sz="1350" dirty="0"/>
           </a:p>
@@ -18042,7 +18042,7 @@
                 <a:ea typeface="Calibri" pitchFamily="34" charset="-122"/>
                 <a:cs typeface="Calibri" pitchFamily="34" charset="-120"/>
               </a:rPr>
-              <a:t>Спроектирована под собственный SQL Server компании — обращения, справочники и схемы в одной корпоративной базе.</a:t>
+              <a:t>Спроектирована под собственный SQL Server предприятия — обращения, справочники и схемы в одной корпоративной базе.</a:t>
             </a:r>
             <a:endParaRPr lang="en-US" sz="1050" dirty="0"/>
           </a:p>
@@ -18196,7 +18196,7 @@
                 <a:ea typeface="Calibri" pitchFamily="34" charset="-122"/>
                 <a:cs typeface="Calibri" pitchFamily="34" charset="-120"/>
               </a:rPr>
-              <a:t>Координаты разломов и доменов карьера ЮРГ используются в обоих продуктах без расхождений — один и тот же карьер.</a:t>
+              <a:t>Координаты разломов и доменов месторождения используются в обоих продуктах без расхождений — общая геологическая модель объекта.</a:t>
             </a:r>
             <a:endParaRPr lang="en-US" sz="1050" dirty="0"/>
           </a:p>
@@ -18389,7 +18389,7 @@
                 <a:ea typeface="Calibri" pitchFamily="34" charset="-122"/>
                 <a:cs typeface="Calibri" pitchFamily="34" charset="-120"/>
               </a:rPr>
-              <a:t>RG-Gold · Цифровая экосистема мониторинга</a:t>
+              <a:t>Платформы мониторинга и контроля рисков</a:t>
             </a:r>
             <a:endParaRPr lang="en-US" sz="900" dirty="0"/>
           </a:p>
@@ -18577,7 +18577,7 @@
                 <a:ea typeface="Calibri" pitchFamily="34" charset="-122"/>
                 <a:cs typeface="Calibri" pitchFamily="34" charset="-120"/>
               </a:rPr>
-              <a:t>Собственная разработка компании — без зависимости от дорогих иностранных решений</a:t>
+              <a:t>Собственная разработка — без зависимости от дорогих иностранных решений</a:t>
             </a:r>
             <a:endParaRPr lang="en-US" sz="1400" dirty="0"/>
           </a:p>
@@ -18689,7 +18689,7 @@
                 <a:ea typeface="Calibri" pitchFamily="34" charset="-122"/>
                 <a:cs typeface="Calibri" pitchFamily="34" charset="-120"/>
               </a:rPr>
-              <a:t>Своя разработка, свой контроль</a:t>
+              <a:t>Своя разработка, полный контроль</a:t>
             </a:r>
             <a:endParaRPr lang="en-US" sz="1350" dirty="0"/>
           </a:p>
@@ -18731,7 +18731,7 @@
                 <a:ea typeface="Calibri" pitchFamily="34" charset="-122"/>
                 <a:cs typeface="Calibri" pitchFamily="34" charset="-120"/>
               </a:rPr>
-              <a:t>Не аренда стороннего ГГИС/мониторингового ПО — код и данные принадлежат компании.</a:t>
+              <a:t>Не аренда стороннего ГГИС/мониторингового ПО — код и данные остаются у заказчика.</a:t>
             </a:r>
             <a:endParaRPr lang="en-US" sz="1050" dirty="0"/>
           </a:p>
@@ -18885,7 +18885,7 @@
                 <a:ea typeface="Calibri" pitchFamily="34" charset="-122"/>
                 <a:cs typeface="Calibri" pitchFamily="34" charset="-120"/>
               </a:rPr>
-              <a:t>Статические приложения без сложной установки — разворачиваются на любом сервере или хостинге компании.</a:t>
+              <a:t>Статические приложения без сложной установки — разворачиваются на любом сервере или хостинге заказчика.</a:t>
             </a:r>
             <a:endParaRPr lang="en-US" sz="1050" dirty="0"/>
           </a:p>
@@ -19232,7 +19232,7 @@
                 <a:ea typeface="Calibri" pitchFamily="34" charset="-122"/>
                 <a:cs typeface="Calibri" pitchFamily="34" charset="-120"/>
               </a:rPr>
-              <a:t>RG-Gold · Цифровая экосистема мониторинга</a:t>
+              <a:t>Платформы мониторинга и контроля рисков</a:t>
             </a:r>
             <a:endParaRPr lang="en-US" sz="900" dirty="0"/>
           </a:p>
@@ -20383,7 +20383,7 @@
                 <a:ea typeface="Calibri" pitchFamily="34" charset="-122"/>
                 <a:cs typeface="Calibri" pitchFamily="34" charset="-120"/>
               </a:rPr>
-              <a:t>RG-Gold · Цифровая экосистема мониторинга</a:t>
+              <a:t>Платформы мониторинга и контроля рисков</a:t>
             </a:r>
             <a:endParaRPr lang="en-US" sz="900" dirty="0"/>
           </a:p>
@@ -21226,7 +21226,7 @@
                 <a:ea typeface="Calibri" pitchFamily="34" charset="-122"/>
                 <a:cs typeface="Calibri" pitchFamily="34" charset="-120"/>
               </a:rPr>
-              <a:t>RG-Gold · Цифровая экосистема мониторинга</a:t>
+              <a:t>Платформы мониторинга и контроля рисков</a:t>
             </a:r>
             <a:endParaRPr lang="en-US" sz="900" dirty="0"/>
           </a:p>
@@ -21312,7 +21312,7 @@
         <p:spPr>
           <a:xfrm>
             <a:off x="502920" y="640080"/>
-            <a:ext cx="7315200" cy="365760"/>
+            <a:ext cx="9144000" cy="365760"/>
           </a:xfrm>
           <a:prstGeom prst="rect">
             <a:avLst/>
@@ -21336,7 +21336,7 @@
                 <a:ea typeface="Calibri" pitchFamily="34" charset="-122"/>
                 <a:cs typeface="Calibri" pitchFamily="34" charset="-120"/>
               </a:rPr>
-              <a:t>RG-GOLD  ·  КАРЬЕР ЮРГ</a:t>
+              <a:t>НАШИ РАЗРАБОТКИ  ·  ПОРТФОЛИО ПЛАТФОРМ</a:t>
             </a:r>
             <a:endParaRPr lang="en-US" sz="1300" dirty="0"/>
           </a:p>
@@ -21440,7 +21440,7 @@
                 <a:ea typeface="Calibri" pitchFamily="34" charset="-122"/>
                 <a:cs typeface="Calibri" pitchFamily="34" charset="-120"/>
               </a:rPr>
-              <a:t>Гидрогеологический мониторинг работает в промышленной эксплуатации на карьере ЮРГ.</a:t>
+              <a:t>Гидрогеологический мониторинг уже работает в промышленной эксплуатации на реальном производственном объекте.</a:t>
             </a:r>
             <a:endParaRPr lang="en-US" sz="1350" dirty="0"/>
           </a:p>
@@ -21460,7 +21460,7 @@
                 <a:ea typeface="Calibri" pitchFamily="34" charset="-122"/>
                 <a:cs typeface="Calibri" pitchFamily="34" charset="-120"/>
               </a:rPr>
-              <a:t>Фиксация рисков — протестированная модель, готовая к подключению к производственной БД предприятия.</a:t>
+              <a:t>Фиксация рисков — протестированная модель, готовая к подключению к боевой базе данных заказчика.</a:t>
             </a:r>
             <a:endParaRPr lang="en-US" sz="1350" dirty="0"/>
           </a:p>
@@ -21543,7 +21543,7 @@
                 <a:ea typeface="Calibri" pitchFamily="34" charset="-122"/>
                 <a:cs typeface="Calibri" pitchFamily="34" charset="-120"/>
               </a:rPr>
-              <a:t>RG-Gold · Цифровая экосистема мониторинга</a:t>
+              <a:t>Платформы мониторинга и контроля рисков</a:t>
             </a:r>
             <a:endParaRPr lang="en-US" sz="900" dirty="0"/>
           </a:p>
@@ -21653,7 +21653,7 @@
                 <a:ea typeface="Calibri" pitchFamily="34" charset="-122"/>
                 <a:cs typeface="Calibri" pitchFamily="34" charset="-120"/>
               </a:rPr>
-              <a:t>ЭКОСИСТЕМА RG-GOLD</a:t>
+              <a:t>НАШИ ПРОДУКТЫ</a:t>
             </a:r>
             <a:endParaRPr lang="en-US" sz="1200" dirty="0"/>
           </a:p>
@@ -21731,7 +21731,7 @@
                 <a:ea typeface="Calibri" pitchFamily="34" charset="-122"/>
                 <a:cs typeface="Calibri" pitchFamily="34" charset="-120"/>
               </a:rPr>
-              <a:t>Разные задачи — общий подход: карта участка, единая база данных, простота эксплуатации</a:t>
+              <a:t>Разные задачи — общий подход: карта объекта, единая база данных, простота эксплуатации</a:t>
             </a:r>
             <a:endParaRPr lang="en-US" sz="1400" dirty="0"/>
           </a:p>
@@ -21885,7 +21885,7 @@
                 <a:ea typeface="Calibri" pitchFamily="34" charset="-122"/>
                 <a:cs typeface="Calibri" pitchFamily="34" charset="-120"/>
               </a:rPr>
-              <a:t>Скважины, точки наблюдения, канавы, водоотлив, пылеподавление, аналитика и ИИ-отчёты. В промышленной эксплуатации на карьере ЮРГ.</a:t>
+              <a:t>Скважины, точки наблюдения, канавы, водоотлив, пылеподавление, аналитика и ИИ-отчёты. Проверено в промышленной эксплуатации на реальном производственном объекте.</a:t>
             </a:r>
             <a:endParaRPr lang="en-US" sz="1050" dirty="0"/>
           </a:p>
@@ -22039,7 +22039,7 @@
                 <a:ea typeface="Calibri" pitchFamily="34" charset="-122"/>
                 <a:cs typeface="Calibri" pitchFamily="34" charset="-120"/>
               </a:rPr>
-              <a:t>Журнал обращений по рискам на участках, карта, справочники и отчёты. Готовая тестовая модель, спецификация для подключения к БД предприятия готова.</a:t>
+              <a:t>Журнал обращений по рискам на объектах, карта, справочники и отчёты. Готовая протестированная модель, контракт для подключения к боевой базе данных полностью специфицирован.</a:t>
             </a:r>
             <a:endParaRPr lang="en-US" sz="1050" dirty="0"/>
           </a:p>
@@ -22193,7 +22193,7 @@
                 <a:ea typeface="Calibri" pitchFamily="34" charset="-122"/>
                 <a:cs typeface="Calibri" pitchFamily="34" charset="-120"/>
               </a:rPr>
-              <a:t>Реальные координаты разломов и доменов карьера ЮРГ (437 линий, 5 доменов) перенесены между проектами один в один — это один и тот же карьер.</a:t>
+              <a:t>Реальные координаты разломов и геологических доменов (437 линий, 5 доменов) переносятся между продуктами без расхождений — общая геологическая модель объекта.</a:t>
             </a:r>
             <a:endParaRPr lang="en-US" sz="1050" dirty="0"/>
           </a:p>
@@ -22386,7 +22386,7 @@
                 <a:ea typeface="Calibri" pitchFamily="34" charset="-122"/>
                 <a:cs typeface="Calibri" pitchFamily="34" charset="-120"/>
               </a:rPr>
-              <a:t>RG-Gold · Цифровая экосистема мониторинга</a:t>
+              <a:t>Платформы мониторинга и контроля рисков</a:t>
             </a:r>
             <a:endParaRPr lang="en-US" sz="900" dirty="0"/>
           </a:p>
@@ -22597,7 +22597,7 @@
                 <a:ea typeface="Calibri" pitchFamily="34" charset="-122"/>
                 <a:cs typeface="Calibri" pitchFamily="34" charset="-120"/>
               </a:rPr>
-              <a:t>Цифровая платформа гидрогеологической службы карьера ЮРГ — в промышленной эксплуатации</a:t>
+              <a:t>Платформа для гидрогеологической службы горнодобывающего предприятия — проверена в промышленной эксплуатации</a:t>
             </a:r>
             <a:endParaRPr lang="en-US" sz="1500" dirty="0"/>
           </a:p>
@@ -22680,7 +22680,7 @@
                 <a:ea typeface="Calibri" pitchFamily="34" charset="-122"/>
                 <a:cs typeface="Calibri" pitchFamily="34" charset="-120"/>
               </a:rPr>
-              <a:t>RG-Gold · Цифровая экосистема мониторинга</a:t>
+              <a:t>Платформы мониторинга и контроля рисков</a:t>
             </a:r>
             <a:endParaRPr lang="en-US" sz="900" dirty="0"/>
           </a:p>
@@ -23528,7 +23528,7 @@
                 <a:ea typeface="Calibri" pitchFamily="34" charset="-122"/>
                 <a:cs typeface="Calibri" pitchFamily="34" charset="-120"/>
               </a:rPr>
-              <a:t>RG-Gold · Цифровая экосистема мониторинга</a:t>
+              <a:t>Платформы мониторинга и контроля рисков</a:t>
             </a:r>
             <a:endParaRPr lang="en-US" sz="900" dirty="0"/>
           </a:p>
@@ -23716,7 +23716,7 @@
                 <a:ea typeface="Calibri" pitchFamily="34" charset="-122"/>
                 <a:cs typeface="Calibri" pitchFamily="34" charset="-120"/>
               </a:rPr>
-              <a:t>Интерактивная схема карьера с точками, канавами и слоями геологии</a:t>
+              <a:t>Интерактивная схема объекта с точками, канавами и слоями геологии</a:t>
             </a:r>
             <a:endParaRPr lang="en-US" sz="1400" dirty="0"/>
           </a:p>
@@ -24679,7 +24679,7 @@
                 <a:ea typeface="Calibri" pitchFamily="34" charset="-122"/>
                 <a:cs typeface="Calibri" pitchFamily="34" charset="-120"/>
               </a:rPr>
-              <a:t>RG-Gold · Цифровая экосистема мониторинга</a:t>
+              <a:t>Платформы мониторинга и контроля рисков</a:t>
             </a:r>
             <a:endParaRPr lang="en-US" sz="900" dirty="0"/>
           </a:p>
@@ -24867,7 +24867,7 @@
                 <a:ea typeface="Calibri" pitchFamily="34" charset="-122"/>
                 <a:cs typeface="Calibri" pitchFamily="34" charset="-120"/>
               </a:rPr>
-              <a:t>Реальные геологические данные карьера ЮРГ — не условная схема</a:t>
+              <a:t>Реальные геологические данные месторождения — не условная схема</a:t>
             </a:r>
             <a:endParaRPr lang="en-US" sz="1400" dirty="0"/>
           </a:p>
@@ -24968,7 +24968,7 @@
                 <a:ea typeface="Calibri" pitchFamily="34" charset="-122"/>
                 <a:cs typeface="Calibri" pitchFamily="34" charset="-120"/>
               </a:rPr>
-              <a:t>437 линий, 1380 точек — фактическая геология карьера, только просмотр слоя.</a:t>
+              <a:t>437 линий, 1380 точек — фактическая геология объекта, только просмотр слоя.</a:t>
             </a:r>
             <a:endParaRPr lang="en-US" sz="1100" dirty="0"/>
           </a:p>
@@ -25271,7 +25271,7 @@
                 <a:ea typeface="Calibri" pitchFamily="34" charset="-122"/>
                 <a:cs typeface="Calibri" pitchFamily="34" charset="-120"/>
               </a:rPr>
-              <a:t>Эти же координаты один в один используются в «Фиксации рисков» — общая геологическая модель карьера.</a:t>
+              <a:t>Эти же координаты один в один используются во втором продукте — общая геологическая модель объекта.</a:t>
             </a:r>
             <a:endParaRPr lang="en-US" sz="1100" dirty="0"/>
           </a:p>
@@ -25332,7 +25332,7 @@
                 <a:ea typeface="Calibri" pitchFamily="34" charset="-122"/>
                 <a:cs typeface="Calibri" pitchFamily="34" charset="-120"/>
               </a:rPr>
-              <a:t>ГЕООСНОВА КАРЬЕРА</a:t>
+              <a:t>ТОЧНОСТЬ ГЕОМОДЕЛИ</a:t>
             </a:r>
             <a:endParaRPr lang="en-US" sz="1300" dirty="0"/>
           </a:p>
@@ -25488,7 +25488,7 @@
                 <a:ea typeface="Calibri" pitchFamily="34" charset="-122"/>
                 <a:cs typeface="Calibri" pitchFamily="34" charset="-120"/>
               </a:rPr>
-              <a:t>доменов · 8 бортов карьера</a:t>
+              <a:t>доменов · 8 бортов объекта</a:t>
             </a:r>
             <a:endParaRPr lang="en-US" sz="1050" dirty="0"/>
           </a:p>
@@ -25527,7 +25527,7 @@
                 <a:ea typeface="Calibri" pitchFamily="34" charset="-122"/>
                 <a:cs typeface="Calibri" pitchFamily="34" charset="-120"/>
               </a:rPr>
-              <a:t>RG-Gold · Цифровая экосистема мониторинга</a:t>
+              <a:t>Платформы мониторинга и контроля рисков</a:t>
             </a:r>
             <a:endParaRPr lang="en-US" sz="900" dirty="0"/>
           </a:p>
@@ -26678,7 +26678,7 @@
                 <a:ea typeface="Calibri" pitchFamily="34" charset="-122"/>
                 <a:cs typeface="Calibri" pitchFamily="34" charset="-120"/>
               </a:rPr>
-              <a:t>RG-Gold · Цифровая экосистема мониторинга</a:t>
+              <a:t>Платформы мониторинга и контроля рисков</a:t>
             </a:r>
             <a:endParaRPr lang="en-US" sz="900" dirty="0"/>
           </a:p>
@@ -27526,7 +27526,7 @@
                 <a:ea typeface="Calibri" pitchFamily="34" charset="-122"/>
                 <a:cs typeface="Calibri" pitchFamily="34" charset="-120"/>
               </a:rPr>
-              <a:t>RG-Gold · Цифровая экосистема мониторинга</a:t>
+              <a:t>Платформы мониторинга и контроля рисков</a:t>
             </a:r>
             <a:endParaRPr lang="en-US" sz="900" dirty="0"/>
           </a:p>

</xml_diff>